<commit_message>
docs: add real-output example slides (dashboard + knowledge graph) to team deck
Add two "실제 화면" example slides after slide 10 of the team-introduction deck,
built from genuine tool output (not AI illustrations):

- Slide 11: the audit --format html dashboard hero, captured as a real headless
  Chrome screenshot (result / findings / documents / orphans / unresolved links
  + project detection).
- Slide 12: the knowledge graph from `graph --format json` real data (24 docs,
  57 links) rendered with networkx — index entry hub, core-doc cluster, and the
  release-notes fan off the log hub. Categorical palette validated for CVD.

Existing slides renumbered (팀은 네 단계 -> 13, closing -> 14); deck now 14
slides. python-pptx round-trip clean; layouts verified by a human in PowerPoint.
Append log.md.

Co-Authored-By: Claude Opus 4.8 (1M context) <noreply@anthropic.com>
</commit_message>
<xml_diff>
--- a/outputs/llm-wiki-team-introduction-v1.5.1.pptx
+++ b/outputs/llm-wiki-team-introduction-v1.5.1.pptx
@@ -18,6 +18,8 @@
     <p:sldId id="263" r:id="rId9"/>
     <p:sldId id="264" r:id="rId10"/>
     <p:sldId id="265" r:id="rId11"/>
+    <p:sldId id="268" r:id="rId19"/>
+    <p:sldId id="269" r:id="rId20"/>
     <p:sldId id="266" r:id="rId12"/>
     <p:sldId id="267" r:id="rId13"/>
   </p:sldIdLst>
@@ -3151,7 +3153,7 @@
 </file>
 
 <file path=ppt/slides/slide11.xml><?xml version="1.0" encoding="utf-8"?>
-<p:sld xmlns:a="http://schemas.openxmlformats.org/drawingml/2006/main" xmlns:r="http://schemas.openxmlformats.org/officeDocument/2006/relationships" xmlns:p="http://schemas.openxmlformats.org/presentationml/2006/main">
+<p:sld xmlns:a="http://schemas.openxmlformats.org/drawingml/2006/main" xmlns:p="http://schemas.openxmlformats.org/presentationml/2006/main" xmlns:r="http://schemas.openxmlformats.org/officeDocument/2006/relationships">
   <p:cSld>
     <p:bg>
       <p:bgPr>
@@ -3167,20 +3169,13 @@
         <p:cNvGrpSpPr/>
         <p:nvPr/>
       </p:nvGrpSpPr>
-      <p:grpSpPr>
-        <a:xfrm>
-          <a:off x="0" y="0"/>
-          <a:ext cx="0" cy="0"/>
-          <a:chOff x="0" y="0"/>
-          <a:chExt cx="0" cy="0"/>
-        </a:xfrm>
-      </p:grpSpPr>
-      <p:sp>
-        <p:nvSpPr>
-          <p:cNvPr id="8" name="직사각형 7">
-            <a:extLst>
-              <a:ext uri="{FF2B5EF4-FFF2-40B4-BE49-F238E27FC236}">
-                <a16:creationId xmlns:a16="http://schemas.microsoft.com/office/drawing/2014/main" id="{18B56F01-11CB-45C3-A80E-84689FA0DF40}"/>
+      <p:grpSpPr/>
+      <p:sp>
+        <p:nvSpPr>
+          <p:cNvPr id="15" name="직사각형 14">
+            <a:extLst>
+              <a:ext uri="{FF2B5EF4-FFF2-40B4-BE49-F238E27FC236}">
+                <a16:creationId xmlns:a16="http://schemas.microsoft.com/office/drawing/2014/main" id="{A50958BA-1905-45A5-8C34-A3CCE237DEC7}"/>
               </a:ext>
             </a:extLst>
           </p:cNvPr>
@@ -3238,7 +3233,7 @@
           <p:cNvPr id="2" name="직사각형 1">
             <a:extLst>
               <a:ext uri="{FF2B5EF4-FFF2-40B4-BE49-F238E27FC236}">
-                <a16:creationId xmlns:a16="http://schemas.microsoft.com/office/drawing/2014/main" id="{2FD06A99-0AC9-490C-A98E-07DBF335A7DC}"/>
+                <a16:creationId xmlns:a16="http://schemas.microsoft.com/office/drawing/2014/main" id="{278384C7-B16A-4E1D-B257-E6E68F4B4C33}"/>
               </a:ext>
             </a:extLst>
           </p:cNvPr>
@@ -3263,7 +3258,7 @@
         </p:spPr>
         <p:txBody>
           <a:bodyPr wrap="square" lIns="0" tIns="0" rIns="0" bIns="0" anchor="ctr">
-            <a:normAutofit/>
+            <a:normAutofit fontScale="85592"/>
           </a:bodyPr>
           <a:lstStyle/>
           <a:p>
@@ -3286,7 +3281,7 @@
                 <a:ea typeface="에스코어 드림 5 Medium"/>
                 <a:cs typeface="에스코어 드림 5 Medium"/>
               </a:rPr>
-              <a:t>팀은 네 단계만 기억하면 됩니다</a:t>
+              <a:t>실제 화면: llm-wiki가 만드는 대시보드</a:t>
             </a:r>
           </a:p>
         </p:txBody>
@@ -3296,7 +3291,7 @@
           <p:cNvPr id="3" name="직사각형 2">
             <a:extLst>
               <a:ext uri="{FF2B5EF4-FFF2-40B4-BE49-F238E27FC236}">
-                <a16:creationId xmlns:a16="http://schemas.microsoft.com/office/drawing/2014/main" id="{9FEA1835-074C-44CD-AECC-606AD36EEC6F}"/>
+                <a16:creationId xmlns:a16="http://schemas.microsoft.com/office/drawing/2014/main" id="{8E6B4BDC-6C83-4771-9772-0B1655F37A90}"/>
               </a:ext>
             </a:extLst>
           </p:cNvPr>
@@ -3351,62 +3346,22 @@
       </p:sp>
       <p:sp>
         <p:nvSpPr>
-          <p:cNvPr id="4" name="타원 3">
-            <a:extLst>
-              <a:ext uri="{FF2B5EF4-FFF2-40B4-BE49-F238E27FC236}">
-                <a16:creationId xmlns:a16="http://schemas.microsoft.com/office/drawing/2014/main" id="{FA783CAA-05EF-4059-8E67-84EB21D3E06C}"/>
-              </a:ext>
-            </a:extLst>
-          </p:cNvPr>
-          <p:cNvSpPr>
-            <a:spLocks noGrp="1"/>
-          </p:cNvSpPr>
-          <p:nvPr/>
-        </p:nvSpPr>
-        <p:spPr>
-          <a:xfrm>
-            <a:off x="571500" y="1733550"/>
-            <a:ext cx="609600" cy="609600"/>
-          </a:xfrm>
-          <a:prstGeom prst="ellipse">
-            <a:avLst/>
-          </a:prstGeom>
-          <a:solidFill>
-            <a:srgbClr val="111111"/>
-          </a:solidFill>
-          <a:ln w="9525">
-            <a:solidFill>
-              <a:srgbClr val="111111"/>
-            </a:solidFill>
-            <a:prstDash val="solid"/>
-          </a:ln>
-        </p:spPr>
-        <p:txBody>
-          <a:bodyPr/>
-          <a:lstStyle/>
-          <a:p>
-            <a:endParaRPr lang="ko-KR" altLang="en-US"/>
-          </a:p>
-        </p:txBody>
-      </p:sp>
-      <p:sp>
-        <p:nvSpPr>
-          <p:cNvPr id="5" name="직사각형 4">
-            <a:extLst>
-              <a:ext uri="{FF2B5EF4-FFF2-40B4-BE49-F238E27FC236}">
-                <a16:creationId xmlns:a16="http://schemas.microsoft.com/office/drawing/2014/main" id="{9EF3961E-086E-46D0-ABEA-EA3EFD588D5E}"/>
-              </a:ext>
-            </a:extLst>
-          </p:cNvPr>
-          <p:cNvSpPr>
-            <a:spLocks noGrp="1"/>
-          </p:cNvSpPr>
-          <p:nvPr/>
-        </p:nvSpPr>
-        <p:spPr>
-          <a:xfrm>
-            <a:off x="571500" y="1924192"/>
-            <a:ext cx="609600" cy="267645"/>
+          <p:cNvPr id="14" name="직사각형 13">
+            <a:extLst>
+              <a:ext uri="{FF2B5EF4-FFF2-40B4-BE49-F238E27FC236}">
+                <a16:creationId xmlns:a16="http://schemas.microsoft.com/office/drawing/2014/main" id="{2CD7065B-DC54-42AB-B1CC-05DD9900677D}"/>
+              </a:ext>
+            </a:extLst>
+          </p:cNvPr>
+          <p:cNvSpPr>
+            <a:spLocks noGrp="1"/>
+          </p:cNvSpPr>
+          <p:nvPr/>
+        </p:nvSpPr>
+        <p:spPr>
+          <a:xfrm>
+            <a:off x="400050" y="6324600"/>
+            <a:ext cx="4000500" cy="228600"/>
           </a:xfrm>
           <a:prstGeom prst="rect">
             <a:avLst/>
@@ -3423,1053 +3378,6 @@
           </a:bodyPr>
           <a:lstStyle/>
           <a:p>
-            <a:pPr algn="ctr">
-              <a:defRPr sz="1650" b="1">
-                <a:solidFill>
-                  <a:srgbClr val="FFFFFF"/>
-                </a:solidFill>
-                <a:latin typeface="에스코어 드림 5 Medium"/>
-                <a:ea typeface="에스코어 드림 5 Medium"/>
-                <a:cs typeface="에스코어 드림 5 Medium"/>
-              </a:defRPr>
-            </a:pPr>
-            <a:r>
-              <a:rPr lang="en-US" altLang="ko-KR" sz="1650" b="1" dirty="0">
-                <a:solidFill>
-                  <a:srgbClr val="FFFFFF"/>
-                </a:solidFill>
-                <a:latin typeface="에스코어 드림 5 Medium"/>
-                <a:ea typeface="에스코어 드림 5 Medium"/>
-                <a:cs typeface="에스코어 드림 5 Medium"/>
-              </a:rPr>
-              <a:t>1</a:t>
-            </a:r>
-          </a:p>
-        </p:txBody>
-      </p:sp>
-      <p:sp>
-        <p:nvSpPr>
-          <p:cNvPr id="6" name="직사각형 5">
-            <a:extLst>
-              <a:ext uri="{FF2B5EF4-FFF2-40B4-BE49-F238E27FC236}">
-                <a16:creationId xmlns:a16="http://schemas.microsoft.com/office/drawing/2014/main" id="{3F414D70-12C4-4023-8483-C79D0F14608E}"/>
-              </a:ext>
-            </a:extLst>
-          </p:cNvPr>
-          <p:cNvSpPr>
-            <a:spLocks noGrp="1"/>
-          </p:cNvSpPr>
-          <p:nvPr/>
-        </p:nvSpPr>
-        <p:spPr>
-          <a:xfrm>
-            <a:off x="1504950" y="1714500"/>
-            <a:ext cx="4000500" cy="419100"/>
-          </a:xfrm>
-          <a:prstGeom prst="rect">
-            <a:avLst/>
-          </a:prstGeom>
-          <a:noFill/>
-          <a:ln w="0">
-            <a:noFill/>
-            <a:prstDash val="solid"/>
-          </a:ln>
-        </p:spPr>
-        <p:txBody>
-          <a:bodyPr wrap="square" lIns="0" tIns="0" rIns="0" bIns="0" anchor="t">
-            <a:normAutofit/>
-          </a:bodyPr>
-          <a:lstStyle/>
-          <a:p>
-            <a:pPr algn="l">
-              <a:defRPr sz="2025" b="1">
-                <a:solidFill>
-                  <a:srgbClr val="111111"/>
-                </a:solidFill>
-                <a:latin typeface="에스코어 드림 5 Medium"/>
-                <a:ea typeface="에스코어 드림 5 Medium"/>
-                <a:cs typeface="에스코어 드림 5 Medium"/>
-              </a:defRPr>
-            </a:pPr>
-            <a:r>
-              <a:rPr lang="ko-KR" altLang="en-US" sz="2025" b="1">
-                <a:solidFill>
-                  <a:srgbClr val="111111"/>
-                </a:solidFill>
-                <a:latin typeface="에스코어 드림 5 Medium"/>
-                <a:ea typeface="에스코어 드림 5 Medium"/>
-                <a:cs typeface="에스코어 드림 5 Medium"/>
-              </a:rPr>
-              <a:t>항상 </a:t>
-            </a:r>
-            <a:r>
-              <a:rPr lang="en-US" altLang="ko-KR" sz="2025" b="1">
-                <a:solidFill>
-                  <a:srgbClr val="111111"/>
-                </a:solidFill>
-                <a:latin typeface="에스코어 드림 5 Medium"/>
-                <a:ea typeface="에스코어 드림 5 Medium"/>
-                <a:cs typeface="에스코어 드림 5 Medium"/>
-              </a:rPr>
-              <a:t>index.md</a:t>
-            </a:r>
-            <a:r>
-              <a:rPr lang="ko-KR" altLang="en-US" sz="2025" b="1">
-                <a:solidFill>
-                  <a:srgbClr val="111111"/>
-                </a:solidFill>
-                <a:latin typeface="에스코어 드림 5 Medium"/>
-                <a:ea typeface="에스코어 드림 5 Medium"/>
-                <a:cs typeface="에스코어 드림 5 Medium"/>
-              </a:rPr>
-              <a:t>에서 시작</a:t>
-            </a:r>
-          </a:p>
-        </p:txBody>
-      </p:sp>
-      <p:sp>
-        <p:nvSpPr>
-          <p:cNvPr id="7" name="직사각형 6">
-            <a:extLst>
-              <a:ext uri="{FF2B5EF4-FFF2-40B4-BE49-F238E27FC236}">
-                <a16:creationId xmlns:a16="http://schemas.microsoft.com/office/drawing/2014/main" id="{36E4E0E3-A99D-4143-B601-0B9576305E12}"/>
-              </a:ext>
-            </a:extLst>
-          </p:cNvPr>
-          <p:cNvSpPr>
-            <a:spLocks noGrp="1"/>
-          </p:cNvSpPr>
-          <p:nvPr/>
-        </p:nvSpPr>
-        <p:spPr>
-          <a:xfrm>
-            <a:off x="5619750" y="1733550"/>
-            <a:ext cx="5810250" cy="533400"/>
-          </a:xfrm>
-          <a:prstGeom prst="rect">
-            <a:avLst/>
-          </a:prstGeom>
-          <a:noFill/>
-          <a:ln w="0">
-            <a:noFill/>
-            <a:prstDash val="solid"/>
-          </a:ln>
-        </p:spPr>
-        <p:txBody>
-          <a:bodyPr wrap="square" lIns="0" tIns="0" rIns="0" bIns="0" anchor="ctr">
-            <a:normAutofit/>
-          </a:bodyPr>
-          <a:lstStyle/>
-          <a:p>
-            <a:pPr algn="l">
-              <a:defRPr sz="1575" b="0">
-                <a:solidFill>
-                  <a:srgbClr val="5F6368"/>
-                </a:solidFill>
-                <a:latin typeface="에스코어 드림 5 Medium"/>
-                <a:ea typeface="에스코어 드림 5 Medium"/>
-                <a:cs typeface="에스코어 드림 5 Medium"/>
-              </a:defRPr>
-            </a:pPr>
-            <a:r>
-              <a:rPr lang="ko-KR" altLang="en-US" sz="1575" b="0">
-                <a:solidFill>
-                  <a:srgbClr val="5F6368"/>
-                </a:solidFill>
-                <a:latin typeface="에스코어 드림 5 Medium"/>
-                <a:ea typeface="에스코어 드림 5 Medium"/>
-                <a:cs typeface="에스코어 드림 5 Medium"/>
-              </a:rPr>
-              <a:t>프로젝트 지식의 공식 입구를 하나로 통일합니다</a:t>
-            </a:r>
-            <a:r>
-              <a:rPr lang="en-US" altLang="ko-KR" sz="1575" b="0">
-                <a:solidFill>
-                  <a:srgbClr val="5F6368"/>
-                </a:solidFill>
-                <a:latin typeface="에스코어 드림 5 Medium"/>
-                <a:ea typeface="에스코어 드림 5 Medium"/>
-                <a:cs typeface="에스코어 드림 5 Medium"/>
-              </a:rPr>
-              <a:t>.</a:t>
-            </a:r>
-          </a:p>
-        </p:txBody>
-      </p:sp>
-      <p:cxnSp>
-        <p:nvCxnSpPr>
-          <p:cNvPr id="31" name="직선 화살표 연결선 30"/>
-          <p:cNvCxnSpPr/>
-          <p:nvPr/>
-        </p:nvCxnSpPr>
-        <p:spPr>
-          <a:xfrm>
-            <a:off x="876300" y="2400300"/>
-            <a:ext cx="0" cy="342900"/>
-          </a:xfrm>
-          <a:prstGeom prst="straightConnector1">
-            <a:avLst/>
-          </a:prstGeom>
-          <a:ln w="19050">
-            <a:solidFill>
-              <a:srgbClr val="DADCE0"/>
-            </a:solidFill>
-            <a:prstDash val="solid"/>
-          </a:ln>
-        </p:spPr>
-      </p:cxnSp>
-      <p:sp>
-        <p:nvSpPr>
-          <p:cNvPr id="9" name="타원 8">
-            <a:extLst>
-              <a:ext uri="{FF2B5EF4-FFF2-40B4-BE49-F238E27FC236}">
-                <a16:creationId xmlns:a16="http://schemas.microsoft.com/office/drawing/2014/main" id="{066ACBC1-FE7C-48AA-9DCB-6511520E3F76}"/>
-              </a:ext>
-            </a:extLst>
-          </p:cNvPr>
-          <p:cNvSpPr>
-            <a:spLocks noGrp="1"/>
-          </p:cNvSpPr>
-          <p:nvPr/>
-        </p:nvSpPr>
-        <p:spPr>
-          <a:xfrm>
-            <a:off x="571500" y="2781300"/>
-            <a:ext cx="609600" cy="609600"/>
-          </a:xfrm>
-          <a:prstGeom prst="ellipse">
-            <a:avLst/>
-          </a:prstGeom>
-          <a:solidFill>
-            <a:srgbClr val="111111"/>
-          </a:solidFill>
-          <a:ln w="9525">
-            <a:solidFill>
-              <a:srgbClr val="111111"/>
-            </a:solidFill>
-            <a:prstDash val="solid"/>
-          </a:ln>
-        </p:spPr>
-        <p:txBody>
-          <a:bodyPr/>
-          <a:lstStyle/>
-          <a:p>
-            <a:endParaRPr lang="ko-KR" altLang="en-US"/>
-          </a:p>
-        </p:txBody>
-      </p:sp>
-      <p:sp>
-        <p:nvSpPr>
-          <p:cNvPr id="10" name="직사각형 9">
-            <a:extLst>
-              <a:ext uri="{FF2B5EF4-FFF2-40B4-BE49-F238E27FC236}">
-                <a16:creationId xmlns:a16="http://schemas.microsoft.com/office/drawing/2014/main" id="{B6C344BF-399F-4E0E-B0CE-67E78C03AE02}"/>
-              </a:ext>
-            </a:extLst>
-          </p:cNvPr>
-          <p:cNvSpPr>
-            <a:spLocks noGrp="1"/>
-          </p:cNvSpPr>
-          <p:nvPr/>
-        </p:nvSpPr>
-        <p:spPr>
-          <a:xfrm>
-            <a:off x="571500" y="2971942"/>
-            <a:ext cx="609600" cy="267645"/>
-          </a:xfrm>
-          <a:prstGeom prst="rect">
-            <a:avLst/>
-          </a:prstGeom>
-          <a:noFill/>
-          <a:ln w="0">
-            <a:noFill/>
-            <a:prstDash val="solid"/>
-          </a:ln>
-        </p:spPr>
-        <p:txBody>
-          <a:bodyPr wrap="square" lIns="0" tIns="0" rIns="0" bIns="0" anchor="t">
-            <a:normAutofit/>
-          </a:bodyPr>
-          <a:lstStyle/>
-          <a:p>
-            <a:pPr algn="ctr">
-              <a:defRPr sz="1650" b="1">
-                <a:solidFill>
-                  <a:srgbClr val="FFFFFF"/>
-                </a:solidFill>
-                <a:latin typeface="에스코어 드림 5 Medium"/>
-                <a:ea typeface="에스코어 드림 5 Medium"/>
-                <a:cs typeface="에스코어 드림 5 Medium"/>
-              </a:defRPr>
-            </a:pPr>
-            <a:r>
-              <a:rPr lang="en-US" altLang="ko-KR" sz="1650" b="1">
-                <a:solidFill>
-                  <a:srgbClr val="FFFFFF"/>
-                </a:solidFill>
-                <a:latin typeface="에스코어 드림 5 Medium"/>
-                <a:ea typeface="에스코어 드림 5 Medium"/>
-                <a:cs typeface="에스코어 드림 5 Medium"/>
-              </a:rPr>
-              <a:t>2</a:t>
-            </a:r>
-          </a:p>
-        </p:txBody>
-      </p:sp>
-      <p:sp>
-        <p:nvSpPr>
-          <p:cNvPr id="11" name="직사각형 10">
-            <a:extLst>
-              <a:ext uri="{FF2B5EF4-FFF2-40B4-BE49-F238E27FC236}">
-                <a16:creationId xmlns:a16="http://schemas.microsoft.com/office/drawing/2014/main" id="{B76AC60E-3818-4DD2-AA2A-809BD055D3FB}"/>
-              </a:ext>
-            </a:extLst>
-          </p:cNvPr>
-          <p:cNvSpPr>
-            <a:spLocks noGrp="1"/>
-          </p:cNvSpPr>
-          <p:nvPr/>
-        </p:nvSpPr>
-        <p:spPr>
-          <a:xfrm>
-            <a:off x="1504950" y="2762250"/>
-            <a:ext cx="4000500" cy="419100"/>
-          </a:xfrm>
-          <a:prstGeom prst="rect">
-            <a:avLst/>
-          </a:prstGeom>
-          <a:noFill/>
-          <a:ln w="0">
-            <a:noFill/>
-            <a:prstDash val="solid"/>
-          </a:ln>
-        </p:spPr>
-        <p:txBody>
-          <a:bodyPr wrap="square" lIns="0" tIns="0" rIns="0" bIns="0" anchor="t">
-            <a:normAutofit/>
-          </a:bodyPr>
-          <a:lstStyle/>
-          <a:p>
-            <a:pPr algn="l">
-              <a:defRPr sz="2025" b="1">
-                <a:solidFill>
-                  <a:srgbClr val="111111"/>
-                </a:solidFill>
-                <a:latin typeface="에스코어 드림 5 Medium"/>
-                <a:ea typeface="에스코어 드림 5 Medium"/>
-                <a:cs typeface="에스코어 드림 5 Medium"/>
-              </a:defRPr>
-            </a:pPr>
-            <a:r>
-              <a:rPr lang="ko-KR" altLang="en-US" sz="2025" b="1">
-                <a:solidFill>
-                  <a:srgbClr val="111111"/>
-                </a:solidFill>
-                <a:latin typeface="에스코어 드림 5 Medium"/>
-                <a:ea typeface="에스코어 드림 5 Medium"/>
-                <a:cs typeface="에스코어 드림 5 Medium"/>
-              </a:rPr>
-              <a:t>설명보다 근거를 확인</a:t>
-            </a:r>
-          </a:p>
-        </p:txBody>
-      </p:sp>
-      <p:sp>
-        <p:nvSpPr>
-          <p:cNvPr id="12" name="직사각형 11">
-            <a:extLst>
-              <a:ext uri="{FF2B5EF4-FFF2-40B4-BE49-F238E27FC236}">
-                <a16:creationId xmlns:a16="http://schemas.microsoft.com/office/drawing/2014/main" id="{C7A9511D-3157-485A-9CE0-97710E488CCF}"/>
-              </a:ext>
-            </a:extLst>
-          </p:cNvPr>
-          <p:cNvSpPr>
-            <a:spLocks noGrp="1"/>
-          </p:cNvSpPr>
-          <p:nvPr/>
-        </p:nvSpPr>
-        <p:spPr>
-          <a:xfrm>
-            <a:off x="5619750" y="2781300"/>
-            <a:ext cx="5810250" cy="533400"/>
-          </a:xfrm>
-          <a:prstGeom prst="rect">
-            <a:avLst/>
-          </a:prstGeom>
-          <a:noFill/>
-          <a:ln w="0">
-            <a:noFill/>
-            <a:prstDash val="solid"/>
-          </a:ln>
-        </p:spPr>
-        <p:txBody>
-          <a:bodyPr wrap="square" lIns="0" tIns="0" rIns="0" bIns="0" anchor="ctr">
-            <a:normAutofit/>
-          </a:bodyPr>
-          <a:lstStyle/>
-          <a:p>
-            <a:pPr algn="l">
-              <a:defRPr sz="1575" b="0">
-                <a:solidFill>
-                  <a:srgbClr val="5F6368"/>
-                </a:solidFill>
-                <a:latin typeface="에스코어 드림 5 Medium"/>
-                <a:ea typeface="에스코어 드림 5 Medium"/>
-                <a:cs typeface="에스코어 드림 5 Medium"/>
-              </a:defRPr>
-            </a:pPr>
-            <a:r>
-              <a:rPr lang="ko-KR" altLang="en-US" sz="1575" b="0">
-                <a:solidFill>
-                  <a:srgbClr val="5F6368"/>
-                </a:solidFill>
-                <a:latin typeface="에스코어 드림 5 Medium"/>
-                <a:ea typeface="에스코어 드림 5 Medium"/>
-                <a:cs typeface="에스코어 드림 5 Medium"/>
-              </a:rPr>
-              <a:t>문서의 </a:t>
-            </a:r>
-            <a:r>
-              <a:rPr lang="en-US" altLang="ko-KR" sz="1575" b="0">
-                <a:solidFill>
-                  <a:srgbClr val="5F6368"/>
-                </a:solidFill>
-                <a:latin typeface="에스코어 드림 5 Medium"/>
-                <a:ea typeface="에스코어 드림 5 Medium"/>
-                <a:cs typeface="에스코어 드림 5 Medium"/>
-              </a:rPr>
-              <a:t>source_files</a:t>
-            </a:r>
-            <a:r>
-              <a:rPr lang="ko-KR" altLang="en-US" sz="1575" b="0">
-                <a:solidFill>
-                  <a:srgbClr val="5F6368"/>
-                </a:solidFill>
-                <a:latin typeface="에스코어 드림 5 Medium"/>
-                <a:ea typeface="에스코어 드림 5 Medium"/>
-                <a:cs typeface="에스코어 드림 5 Medium"/>
-              </a:rPr>
-              <a:t>와 </a:t>
-            </a:r>
-            <a:r>
-              <a:rPr lang="en-US" altLang="ko-KR" sz="1575" b="0">
-                <a:solidFill>
-                  <a:srgbClr val="5F6368"/>
-                </a:solidFill>
-                <a:latin typeface="에스코어 드림 5 Medium"/>
-                <a:ea typeface="에스코어 드림 5 Medium"/>
-                <a:cs typeface="에스코어 드림 5 Medium"/>
-              </a:rPr>
-              <a:t>evidence</a:t>
-            </a:r>
-            <a:r>
-              <a:rPr lang="ko-KR" altLang="en-US" sz="1575" b="0">
-                <a:solidFill>
-                  <a:srgbClr val="5F6368"/>
-                </a:solidFill>
-                <a:latin typeface="에스코어 드림 5 Medium"/>
-                <a:ea typeface="에스코어 드림 5 Medium"/>
-                <a:cs typeface="에스코어 드림 5 Medium"/>
-              </a:rPr>
-              <a:t>를 실제 코드와 대조합니다</a:t>
-            </a:r>
-            <a:r>
-              <a:rPr lang="en-US" altLang="ko-KR" sz="1575" b="0">
-                <a:solidFill>
-                  <a:srgbClr val="5F6368"/>
-                </a:solidFill>
-                <a:latin typeface="에스코어 드림 5 Medium"/>
-                <a:ea typeface="에스코어 드림 5 Medium"/>
-                <a:cs typeface="에스코어 드림 5 Medium"/>
-              </a:rPr>
-              <a:t>.</a:t>
-            </a:r>
-          </a:p>
-        </p:txBody>
-      </p:sp>
-      <p:cxnSp>
-        <p:nvCxnSpPr>
-          <p:cNvPr id="36" name="직선 화살표 연결선 35"/>
-          <p:cNvCxnSpPr/>
-          <p:nvPr/>
-        </p:nvCxnSpPr>
-        <p:spPr>
-          <a:xfrm>
-            <a:off x="876300" y="3448050"/>
-            <a:ext cx="0" cy="342900"/>
-          </a:xfrm>
-          <a:prstGeom prst="straightConnector1">
-            <a:avLst/>
-          </a:prstGeom>
-          <a:ln w="19050">
-            <a:solidFill>
-              <a:srgbClr val="DADCE0"/>
-            </a:solidFill>
-            <a:prstDash val="solid"/>
-          </a:ln>
-        </p:spPr>
-      </p:cxnSp>
-      <p:sp>
-        <p:nvSpPr>
-          <p:cNvPr id="14" name="타원 13">
-            <a:extLst>
-              <a:ext uri="{FF2B5EF4-FFF2-40B4-BE49-F238E27FC236}">
-                <a16:creationId xmlns:a16="http://schemas.microsoft.com/office/drawing/2014/main" id="{10EDA4C5-E48D-42F6-8627-63BCCF7D4B16}"/>
-              </a:ext>
-            </a:extLst>
-          </p:cNvPr>
-          <p:cNvSpPr>
-            <a:spLocks noGrp="1"/>
-          </p:cNvSpPr>
-          <p:nvPr/>
-        </p:nvSpPr>
-        <p:spPr>
-          <a:xfrm>
-            <a:off x="571500" y="3829050"/>
-            <a:ext cx="609600" cy="609600"/>
-          </a:xfrm>
-          <a:prstGeom prst="ellipse">
-            <a:avLst/>
-          </a:prstGeom>
-          <a:solidFill>
-            <a:srgbClr val="111111"/>
-          </a:solidFill>
-          <a:ln w="9525">
-            <a:solidFill>
-              <a:srgbClr val="111111"/>
-            </a:solidFill>
-            <a:prstDash val="solid"/>
-          </a:ln>
-        </p:spPr>
-        <p:txBody>
-          <a:bodyPr/>
-          <a:lstStyle/>
-          <a:p>
-            <a:endParaRPr lang="ko-KR" altLang="en-US"/>
-          </a:p>
-        </p:txBody>
-      </p:sp>
-      <p:sp>
-        <p:nvSpPr>
-          <p:cNvPr id="15" name="직사각형 14">
-            <a:extLst>
-              <a:ext uri="{FF2B5EF4-FFF2-40B4-BE49-F238E27FC236}">
-                <a16:creationId xmlns:a16="http://schemas.microsoft.com/office/drawing/2014/main" id="{1E7970CC-D970-4999-8704-9373BD8EEC86}"/>
-              </a:ext>
-            </a:extLst>
-          </p:cNvPr>
-          <p:cNvSpPr>
-            <a:spLocks noGrp="1"/>
-          </p:cNvSpPr>
-          <p:nvPr/>
-        </p:nvSpPr>
-        <p:spPr>
-          <a:xfrm>
-            <a:off x="571500" y="4019692"/>
-            <a:ext cx="609600" cy="267645"/>
-          </a:xfrm>
-          <a:prstGeom prst="rect">
-            <a:avLst/>
-          </a:prstGeom>
-          <a:noFill/>
-          <a:ln w="0">
-            <a:noFill/>
-            <a:prstDash val="solid"/>
-          </a:ln>
-        </p:spPr>
-        <p:txBody>
-          <a:bodyPr wrap="square" lIns="0" tIns="0" rIns="0" bIns="0" anchor="t">
-            <a:normAutofit/>
-          </a:bodyPr>
-          <a:lstStyle/>
-          <a:p>
-            <a:pPr algn="ctr">
-              <a:defRPr sz="1650" b="1">
-                <a:solidFill>
-                  <a:srgbClr val="FFFFFF"/>
-                </a:solidFill>
-                <a:latin typeface="에스코어 드림 5 Medium"/>
-                <a:ea typeface="에스코어 드림 5 Medium"/>
-                <a:cs typeface="에스코어 드림 5 Medium"/>
-              </a:defRPr>
-            </a:pPr>
-            <a:r>
-              <a:rPr lang="en-US" altLang="ko-KR" sz="1650" b="1">
-                <a:solidFill>
-                  <a:srgbClr val="FFFFFF"/>
-                </a:solidFill>
-                <a:latin typeface="에스코어 드림 5 Medium"/>
-                <a:ea typeface="에스코어 드림 5 Medium"/>
-                <a:cs typeface="에스코어 드림 5 Medium"/>
-              </a:rPr>
-              <a:t>3</a:t>
-            </a:r>
-          </a:p>
-        </p:txBody>
-      </p:sp>
-      <p:sp>
-        <p:nvSpPr>
-          <p:cNvPr id="16" name="직사각형 15">
-            <a:extLst>
-              <a:ext uri="{FF2B5EF4-FFF2-40B4-BE49-F238E27FC236}">
-                <a16:creationId xmlns:a16="http://schemas.microsoft.com/office/drawing/2014/main" id="{1AF24252-A158-4A4F-B5EB-47D8FDFB9546}"/>
-              </a:ext>
-            </a:extLst>
-          </p:cNvPr>
-          <p:cNvSpPr>
-            <a:spLocks noGrp="1"/>
-          </p:cNvSpPr>
-          <p:nvPr/>
-        </p:nvSpPr>
-        <p:spPr>
-          <a:xfrm>
-            <a:off x="1504950" y="3810000"/>
-            <a:ext cx="4000500" cy="419100"/>
-          </a:xfrm>
-          <a:prstGeom prst="rect">
-            <a:avLst/>
-          </a:prstGeom>
-          <a:noFill/>
-          <a:ln w="0">
-            <a:noFill/>
-            <a:prstDash val="solid"/>
-          </a:ln>
-        </p:spPr>
-        <p:txBody>
-          <a:bodyPr wrap="square" lIns="0" tIns="0" rIns="0" bIns="0" anchor="t">
-            <a:normAutofit/>
-          </a:bodyPr>
-          <a:lstStyle/>
-          <a:p>
-            <a:pPr algn="l">
-              <a:defRPr sz="2025" b="1">
-                <a:solidFill>
-                  <a:srgbClr val="111111"/>
-                </a:solidFill>
-                <a:latin typeface="에스코어 드림 5 Medium"/>
-                <a:ea typeface="에스코어 드림 5 Medium"/>
-                <a:cs typeface="에스코어 드림 5 Medium"/>
-              </a:defRPr>
-            </a:pPr>
-            <a:r>
-              <a:rPr lang="ko-KR" altLang="en-US" sz="2025" b="1">
-                <a:solidFill>
-                  <a:srgbClr val="111111"/>
-                </a:solidFill>
-                <a:latin typeface="에스코어 드림 5 Medium"/>
-                <a:ea typeface="에스코어 드림 5 Medium"/>
-                <a:cs typeface="에스코어 드림 5 Medium"/>
-              </a:rPr>
-              <a:t>코드와 위키를 함께 변경</a:t>
-            </a:r>
-          </a:p>
-        </p:txBody>
-      </p:sp>
-      <p:sp>
-        <p:nvSpPr>
-          <p:cNvPr id="17" name="직사각형 16">
-            <a:extLst>
-              <a:ext uri="{FF2B5EF4-FFF2-40B4-BE49-F238E27FC236}">
-                <a16:creationId xmlns:a16="http://schemas.microsoft.com/office/drawing/2014/main" id="{D6F2D7D7-9C66-4423-8A9E-16C6A905782C}"/>
-              </a:ext>
-            </a:extLst>
-          </p:cNvPr>
-          <p:cNvSpPr>
-            <a:spLocks noGrp="1"/>
-          </p:cNvSpPr>
-          <p:nvPr/>
-        </p:nvSpPr>
-        <p:spPr>
-          <a:xfrm>
-            <a:off x="5619750" y="3829050"/>
-            <a:ext cx="5810250" cy="533400"/>
-          </a:xfrm>
-          <a:prstGeom prst="rect">
-            <a:avLst/>
-          </a:prstGeom>
-          <a:noFill/>
-          <a:ln w="0">
-            <a:noFill/>
-            <a:prstDash val="solid"/>
-          </a:ln>
-        </p:spPr>
-        <p:txBody>
-          <a:bodyPr wrap="square" lIns="0" tIns="0" rIns="0" bIns="0" anchor="ctr">
-            <a:normAutofit/>
-          </a:bodyPr>
-          <a:lstStyle/>
-          <a:p>
-            <a:pPr algn="l">
-              <a:defRPr sz="1575" b="0">
-                <a:solidFill>
-                  <a:srgbClr val="5F6368"/>
-                </a:solidFill>
-                <a:latin typeface="에스코어 드림 5 Medium"/>
-                <a:ea typeface="에스코어 드림 5 Medium"/>
-                <a:cs typeface="에스코어 드림 5 Medium"/>
-              </a:defRPr>
-            </a:pPr>
-            <a:r>
-              <a:rPr lang="ko-KR" altLang="en-US" sz="1575" b="0">
-                <a:solidFill>
-                  <a:srgbClr val="5F6368"/>
-                </a:solidFill>
-                <a:latin typeface="에스코어 드림 5 Medium"/>
-                <a:ea typeface="에스코어 드림 5 Medium"/>
-                <a:cs typeface="에스코어 드림 5 Medium"/>
-              </a:rPr>
-              <a:t>기능이 바뀌면 관련 설명과 변경 로그도 같은 작업에서 갱신합니다</a:t>
-            </a:r>
-            <a:r>
-              <a:rPr lang="en-US" altLang="ko-KR" sz="1575" b="0">
-                <a:solidFill>
-                  <a:srgbClr val="5F6368"/>
-                </a:solidFill>
-                <a:latin typeface="에스코어 드림 5 Medium"/>
-                <a:ea typeface="에스코어 드림 5 Medium"/>
-                <a:cs typeface="에스코어 드림 5 Medium"/>
-              </a:rPr>
-              <a:t>.</a:t>
-            </a:r>
-          </a:p>
-        </p:txBody>
-      </p:sp>
-      <p:cxnSp>
-        <p:nvCxnSpPr>
-          <p:cNvPr id="41" name="직선 화살표 연결선 40"/>
-          <p:cNvCxnSpPr/>
-          <p:nvPr/>
-        </p:nvCxnSpPr>
-        <p:spPr>
-          <a:xfrm>
-            <a:off x="876300" y="4495800"/>
-            <a:ext cx="0" cy="342900"/>
-          </a:xfrm>
-          <a:prstGeom prst="straightConnector1">
-            <a:avLst/>
-          </a:prstGeom>
-          <a:ln w="19050">
-            <a:solidFill>
-              <a:srgbClr val="DADCE0"/>
-            </a:solidFill>
-            <a:prstDash val="solid"/>
-          </a:ln>
-        </p:spPr>
-      </p:cxnSp>
-      <p:sp>
-        <p:nvSpPr>
-          <p:cNvPr id="19" name="타원 18">
-            <a:extLst>
-              <a:ext uri="{FF2B5EF4-FFF2-40B4-BE49-F238E27FC236}">
-                <a16:creationId xmlns:a16="http://schemas.microsoft.com/office/drawing/2014/main" id="{ACCEC513-8C8F-4C00-9E73-08B6D13F2D1C}"/>
-              </a:ext>
-            </a:extLst>
-          </p:cNvPr>
-          <p:cNvSpPr>
-            <a:spLocks noGrp="1"/>
-          </p:cNvSpPr>
-          <p:nvPr/>
-        </p:nvSpPr>
-        <p:spPr>
-          <a:xfrm>
-            <a:off x="571500" y="4876800"/>
-            <a:ext cx="609600" cy="609600"/>
-          </a:xfrm>
-          <a:prstGeom prst="ellipse">
-            <a:avLst/>
-          </a:prstGeom>
-          <a:solidFill>
-            <a:srgbClr val="2563EB"/>
-          </a:solidFill>
-          <a:ln w="9525">
-            <a:solidFill>
-              <a:srgbClr val="2563EB"/>
-            </a:solidFill>
-            <a:prstDash val="solid"/>
-          </a:ln>
-        </p:spPr>
-        <p:txBody>
-          <a:bodyPr/>
-          <a:lstStyle/>
-          <a:p>
-            <a:endParaRPr lang="ko-KR" altLang="en-US"/>
-          </a:p>
-        </p:txBody>
-      </p:sp>
-      <p:sp>
-        <p:nvSpPr>
-          <p:cNvPr id="20" name="직사각형 19">
-            <a:extLst>
-              <a:ext uri="{FF2B5EF4-FFF2-40B4-BE49-F238E27FC236}">
-                <a16:creationId xmlns:a16="http://schemas.microsoft.com/office/drawing/2014/main" id="{D7AB8B56-B291-4C41-B0D6-2D8B4D9DAE64}"/>
-              </a:ext>
-            </a:extLst>
-          </p:cNvPr>
-          <p:cNvSpPr>
-            <a:spLocks noGrp="1"/>
-          </p:cNvSpPr>
-          <p:nvPr/>
-        </p:nvSpPr>
-        <p:spPr>
-          <a:xfrm>
-            <a:off x="571500" y="5067442"/>
-            <a:ext cx="609600" cy="267645"/>
-          </a:xfrm>
-          <a:prstGeom prst="rect">
-            <a:avLst/>
-          </a:prstGeom>
-          <a:noFill/>
-          <a:ln w="0">
-            <a:noFill/>
-            <a:prstDash val="solid"/>
-          </a:ln>
-        </p:spPr>
-        <p:txBody>
-          <a:bodyPr wrap="square" lIns="0" tIns="0" rIns="0" bIns="0" anchor="t">
-            <a:normAutofit/>
-          </a:bodyPr>
-          <a:lstStyle/>
-          <a:p>
-            <a:pPr algn="ctr">
-              <a:defRPr sz="1650" b="1">
-                <a:solidFill>
-                  <a:srgbClr val="FFFFFF"/>
-                </a:solidFill>
-                <a:latin typeface="에스코어 드림 5 Medium"/>
-                <a:ea typeface="에스코어 드림 5 Medium"/>
-                <a:cs typeface="에스코어 드림 5 Medium"/>
-              </a:defRPr>
-            </a:pPr>
-            <a:r>
-              <a:rPr lang="en-US" altLang="ko-KR" sz="1650" b="1">
-                <a:solidFill>
-                  <a:srgbClr val="FFFFFF"/>
-                </a:solidFill>
-                <a:latin typeface="에스코어 드림 5 Medium"/>
-                <a:ea typeface="에스코어 드림 5 Medium"/>
-                <a:cs typeface="에스코어 드림 5 Medium"/>
-              </a:rPr>
-              <a:t>4</a:t>
-            </a:r>
-          </a:p>
-        </p:txBody>
-      </p:sp>
-      <p:sp>
-        <p:nvSpPr>
-          <p:cNvPr id="21" name="직사각형 20">
-            <a:extLst>
-              <a:ext uri="{FF2B5EF4-FFF2-40B4-BE49-F238E27FC236}">
-                <a16:creationId xmlns:a16="http://schemas.microsoft.com/office/drawing/2014/main" id="{26A34BAF-9F07-4325-969D-73EC36FC7FAC}"/>
-              </a:ext>
-            </a:extLst>
-          </p:cNvPr>
-          <p:cNvSpPr>
-            <a:spLocks noGrp="1"/>
-          </p:cNvSpPr>
-          <p:nvPr/>
-        </p:nvSpPr>
-        <p:spPr>
-          <a:xfrm>
-            <a:off x="1504950" y="4857750"/>
-            <a:ext cx="4000500" cy="419100"/>
-          </a:xfrm>
-          <a:prstGeom prst="rect">
-            <a:avLst/>
-          </a:prstGeom>
-          <a:noFill/>
-          <a:ln w="0">
-            <a:noFill/>
-            <a:prstDash val="solid"/>
-          </a:ln>
-        </p:spPr>
-        <p:txBody>
-          <a:bodyPr wrap="square" lIns="0" tIns="0" rIns="0" bIns="0" anchor="t">
-            <a:normAutofit/>
-          </a:bodyPr>
-          <a:lstStyle/>
-          <a:p>
-            <a:pPr algn="l">
-              <a:defRPr sz="2025" b="1">
-                <a:solidFill>
-                  <a:srgbClr val="111111"/>
-                </a:solidFill>
-                <a:latin typeface="에스코어 드림 5 Medium"/>
-                <a:ea typeface="에스코어 드림 5 Medium"/>
-                <a:cs typeface="에스코어 드림 5 Medium"/>
-              </a:defRPr>
-            </a:pPr>
-            <a:r>
-              <a:rPr lang="ko-KR" altLang="en-US" sz="2025" b="1">
-                <a:solidFill>
-                  <a:srgbClr val="111111"/>
-                </a:solidFill>
-                <a:latin typeface="에스코어 드림 5 Medium"/>
-                <a:ea typeface="에스코어 드림 5 Medium"/>
-                <a:cs typeface="에스코어 드림 5 Medium"/>
-              </a:rPr>
-              <a:t>사람이 마지막 도장을 찍기</a:t>
-            </a:r>
-          </a:p>
-        </p:txBody>
-      </p:sp>
-      <p:sp>
-        <p:nvSpPr>
-          <p:cNvPr id="22" name="직사각형 21">
-            <a:extLst>
-              <a:ext uri="{FF2B5EF4-FFF2-40B4-BE49-F238E27FC236}">
-                <a16:creationId xmlns:a16="http://schemas.microsoft.com/office/drawing/2014/main" id="{FFD73BD0-EB19-4246-BB9B-F9BFC5A7DFD6}"/>
-              </a:ext>
-            </a:extLst>
-          </p:cNvPr>
-          <p:cNvSpPr>
-            <a:spLocks noGrp="1"/>
-          </p:cNvSpPr>
-          <p:nvPr/>
-        </p:nvSpPr>
-        <p:spPr>
-          <a:xfrm>
-            <a:off x="5619750" y="4876800"/>
-            <a:ext cx="5810250" cy="533400"/>
-          </a:xfrm>
-          <a:prstGeom prst="rect">
-            <a:avLst/>
-          </a:prstGeom>
-          <a:noFill/>
-          <a:ln w="0">
-            <a:noFill/>
-            <a:prstDash val="solid"/>
-          </a:ln>
-        </p:spPr>
-        <p:txBody>
-          <a:bodyPr wrap="square" lIns="0" tIns="0" rIns="0" bIns="0" anchor="ctr">
-            <a:normAutofit/>
-          </a:bodyPr>
-          <a:lstStyle/>
-          <a:p>
-            <a:pPr algn="l">
-              <a:defRPr sz="1575" b="0">
-                <a:solidFill>
-                  <a:srgbClr val="5F6368"/>
-                </a:solidFill>
-                <a:latin typeface="에스코어 드림 5 Medium"/>
-                <a:ea typeface="에스코어 드림 5 Medium"/>
-                <a:cs typeface="에스코어 드림 5 Medium"/>
-              </a:defRPr>
-            </a:pPr>
-            <a:r>
-              <a:rPr lang="en-US" altLang="ko-KR" sz="1575" b="0">
-                <a:solidFill>
-                  <a:srgbClr val="5F6368"/>
-                </a:solidFill>
-                <a:latin typeface="에스코어 드림 5 Medium"/>
-                <a:ea typeface="에스코어 드림 5 Medium"/>
-                <a:cs typeface="에스코어 드림 5 Medium"/>
-              </a:rPr>
-              <a:t>AI </a:t>
-            </a:r>
-            <a:r>
-              <a:rPr lang="ko-KR" altLang="en-US" sz="1575" b="0">
-                <a:solidFill>
-                  <a:srgbClr val="5F6368"/>
-                </a:solidFill>
-                <a:latin typeface="에스코어 드림 5 Medium"/>
-                <a:ea typeface="에스코어 드림 5 Medium"/>
-                <a:cs typeface="에스코어 드림 5 Medium"/>
-              </a:rPr>
-              <a:t>수정본은 </a:t>
-            </a:r>
-            <a:r>
-              <a:rPr lang="en-US" altLang="ko-KR" sz="1575" b="0">
-                <a:solidFill>
-                  <a:srgbClr val="5F6368"/>
-                </a:solidFill>
-                <a:latin typeface="에스코어 드림 5 Medium"/>
-                <a:ea typeface="에스코어 드림 5 Medium"/>
-                <a:cs typeface="에스코어 드림 5 Medium"/>
-              </a:rPr>
-              <a:t>needs_review, </a:t>
-            </a:r>
-            <a:r>
-              <a:rPr lang="ko-KR" altLang="en-US" sz="1575" b="0">
-                <a:solidFill>
-                  <a:srgbClr val="5F6368"/>
-                </a:solidFill>
-                <a:latin typeface="에스코어 드림 5 Medium"/>
-                <a:ea typeface="에스코어 드림 5 Medium"/>
-                <a:cs typeface="에스코어 드림 5 Medium"/>
-              </a:rPr>
-              <a:t>확인이 끝나면 </a:t>
-            </a:r>
-            <a:r>
-              <a:rPr lang="en-US" altLang="ko-KR" sz="1575" b="0">
-                <a:solidFill>
-                  <a:srgbClr val="5F6368"/>
-                </a:solidFill>
-                <a:latin typeface="에스코어 드림 5 Medium"/>
-                <a:ea typeface="에스코어 드림 5 Medium"/>
-                <a:cs typeface="에스코어 드림 5 Medium"/>
-              </a:rPr>
-              <a:t>verified</a:t>
-            </a:r>
-            <a:r>
-              <a:rPr lang="ko-KR" altLang="en-US" sz="1575" b="0">
-                <a:solidFill>
-                  <a:srgbClr val="5F6368"/>
-                </a:solidFill>
-                <a:latin typeface="에스코어 드림 5 Medium"/>
-                <a:ea typeface="에스코어 드림 5 Medium"/>
-                <a:cs typeface="에스코어 드림 5 Medium"/>
-              </a:rPr>
-              <a:t>로 승격합니다</a:t>
-            </a:r>
-            <a:r>
-              <a:rPr lang="en-US" altLang="ko-KR" sz="1575" b="0">
-                <a:solidFill>
-                  <a:srgbClr val="5F6368"/>
-                </a:solidFill>
-                <a:latin typeface="에스코어 드림 5 Medium"/>
-                <a:ea typeface="에스코어 드림 5 Medium"/>
-                <a:cs typeface="에스코어 드림 5 Medium"/>
-              </a:rPr>
-              <a:t>.</a:t>
-            </a:r>
-          </a:p>
-        </p:txBody>
-      </p:sp>
-      <p:sp>
-        <p:nvSpPr>
-          <p:cNvPr id="23" name="직사각형 22">
-            <a:extLst>
-              <a:ext uri="{FF2B5EF4-FFF2-40B4-BE49-F238E27FC236}">
-                <a16:creationId xmlns:a16="http://schemas.microsoft.com/office/drawing/2014/main" id="{D69B8427-04B9-411A-8925-20F6F1081FC4}"/>
-              </a:ext>
-            </a:extLst>
-          </p:cNvPr>
-          <p:cNvSpPr>
-            <a:spLocks noGrp="1"/>
-          </p:cNvSpPr>
-          <p:nvPr/>
-        </p:nvSpPr>
-        <p:spPr>
-          <a:xfrm>
-            <a:off x="400050" y="6324600"/>
-            <a:ext cx="4000500" cy="228600"/>
-          </a:xfrm>
-          <a:prstGeom prst="rect">
-            <a:avLst/>
-          </a:prstGeom>
-          <a:noFill/>
-          <a:ln w="0">
-            <a:noFill/>
-            <a:prstDash val="solid"/>
-          </a:ln>
-        </p:spPr>
-        <p:txBody>
-          <a:bodyPr wrap="square" lIns="0" tIns="0" rIns="0" bIns="0" anchor="t">
-            <a:normAutofit/>
-          </a:bodyPr>
-          <a:lstStyle/>
-          <a:p>
             <a:pPr algn="l">
               <a:defRPr sz="1050" b="0">
                 <a:solidFill>
@@ -4516,12 +3424,70 @@
           </a:p>
         </p:txBody>
       </p:sp>
+      <p:pic>
+        <p:nvPicPr>
+          <p:cNvPr id="16" name="Picture 15" descr="hero.png"/>
+          <p:cNvPicPr>
+            <a:picLocks noChangeAspect="1"/>
+          </p:cNvPicPr>
+          <p:nvPr/>
+        </p:nvPicPr>
+        <p:blipFill>
+          <a:blip r:embed="rId2"/>
+          <a:stretch>
+            <a:fillRect/>
+          </a:stretch>
+        </p:blipFill>
+        <p:spPr>
+          <a:xfrm>
+            <a:off x="883767" y="2148840"/>
+            <a:ext cx="10424160" cy="3539237"/>
+          </a:xfrm>
+          <a:prstGeom prst="rect">
+            <a:avLst/>
+          </a:prstGeom>
+          <a:ln w="12700">
+            <a:solidFill>
+              <a:srgbClr val="D7DDE9"/>
+            </a:solidFill>
+          </a:ln>
+        </p:spPr>
+      </p:pic>
+      <p:sp>
+        <p:nvSpPr>
+          <p:cNvPr id="17" name="TextBox 16"/>
+          <p:cNvSpPr txBox="1"/>
+          <p:nvPr/>
+        </p:nvSpPr>
+        <p:spPr>
+          <a:xfrm>
+            <a:off x="883767" y="5797805"/>
+            <a:ext cx="10424160" cy="457200"/>
+          </a:xfrm>
+          <a:prstGeom prst="rect">
+            <a:avLst/>
+          </a:prstGeom>
+          <a:noFill/>
+        </p:spPr>
+        <p:txBody>
+          <a:bodyPr wrap="square">
+            <a:spAutoFit/>
+          </a:bodyPr>
+          <a:lstStyle/>
+          <a:p>
+            <a:pPr algn="ctr"/>
+            <a:r>
+              <a:rPr sz="1300">
+                <a:solidFill>
+                  <a:srgbClr val="5F6880"/>
+                </a:solidFill>
+              </a:rPr>
+              <a:t>llm-wiki audit --format html 실제 출력 — 결과·발견·문서·고아·링크 상태를 한 화면에서 점검</a:t>
+            </a:r>
+          </a:p>
+        </p:txBody>
+      </p:sp>
     </p:spTree>
-    <p:extLst>
-      <p:ext uri="{BB962C8B-B14F-4D97-AF65-F5344CB8AC3E}">
-        <p14:creationId xmlns:p14="http://schemas.microsoft.com/office/powerpoint/2010/main" val="1242275027"/>
-      </p:ext>
-    </p:extLst>
   </p:cSld>
   <p:clrMapOvr>
     <a:masterClrMapping/>
@@ -4556,6 +3522,1385 @@
       </p:grpSpPr>
       <p:sp>
         <p:nvSpPr>
+          <p:cNvPr id="8" name="직사각형 7">
+            <a:extLst>
+              <a:ext uri="{FF2B5EF4-FFF2-40B4-BE49-F238E27FC236}">
+                <a16:creationId xmlns:a16="http://schemas.microsoft.com/office/drawing/2014/main" id="{18B56F01-11CB-45C3-A80E-84689FA0DF40}"/>
+              </a:ext>
+            </a:extLst>
+          </p:cNvPr>
+          <p:cNvSpPr>
+            <a:spLocks noGrp="1"/>
+          </p:cNvSpPr>
+          <p:nvPr/>
+        </p:nvSpPr>
+        <p:spPr>
+          <a:xfrm>
+            <a:off x="400050" y="323850"/>
+            <a:ext cx="3048000" cy="285750"/>
+          </a:xfrm>
+          <a:prstGeom prst="rect">
+            <a:avLst/>
+          </a:prstGeom>
+          <a:noFill/>
+          <a:ln w="0">
+            <a:noFill/>
+            <a:prstDash val="solid"/>
+          </a:ln>
+        </p:spPr>
+        <p:txBody>
+          <a:bodyPr wrap="square" lIns="0" tIns="0" rIns="0" bIns="0" anchor="t">
+            <a:normAutofit/>
+          </a:bodyPr>
+          <a:lstStyle/>
+          <a:p>
+            <a:pPr algn="l">
+              <a:defRPr sz="1200" b="1">
+                <a:solidFill>
+                  <a:srgbClr val="2563EB"/>
+                </a:solidFill>
+                <a:latin typeface="에스코어 드림 5 Medium"/>
+                <a:ea typeface="에스코어 드림 5 Medium"/>
+                <a:cs typeface="에스코어 드림 5 Medium"/>
+              </a:defRPr>
+            </a:pPr>
+            <a:r>
+              <a:rPr lang="en-US" sz="1200" b="1">
+                <a:solidFill>
+                  <a:srgbClr val="2563EB"/>
+                </a:solidFill>
+                <a:latin typeface="에스코어 드림 5 Medium"/>
+                <a:ea typeface="에스코어 드림 5 Medium"/>
+                <a:cs typeface="에스코어 드림 5 Medium"/>
+              </a:rPr>
+              <a:t>LLM-WIKI 1.5.1</a:t>
+            </a:r>
+          </a:p>
+        </p:txBody>
+      </p:sp>
+      <p:sp>
+        <p:nvSpPr>
+          <p:cNvPr id="2" name="직사각형 1">
+            <a:extLst>
+              <a:ext uri="{FF2B5EF4-FFF2-40B4-BE49-F238E27FC236}">
+                <a16:creationId xmlns:a16="http://schemas.microsoft.com/office/drawing/2014/main" id="{2FD06A99-0AC9-490C-A98E-07DBF335A7DC}"/>
+              </a:ext>
+            </a:extLst>
+          </p:cNvPr>
+          <p:cNvSpPr>
+            <a:spLocks noGrp="1"/>
+          </p:cNvSpPr>
+          <p:nvPr/>
+        </p:nvSpPr>
+        <p:spPr>
+          <a:xfrm>
+            <a:off x="400050" y="723900"/>
+            <a:ext cx="11049000" cy="685800"/>
+          </a:xfrm>
+          <a:prstGeom prst="rect">
+            <a:avLst/>
+          </a:prstGeom>
+          <a:noFill/>
+          <a:ln w="0">
+            <a:noFill/>
+            <a:prstDash val="solid"/>
+          </a:ln>
+        </p:spPr>
+        <p:txBody>
+          <a:bodyPr wrap="square" lIns="0" tIns="0" rIns="0" bIns="0" anchor="ctr">
+            <a:normAutofit/>
+          </a:bodyPr>
+          <a:lstStyle/>
+          <a:p>
+            <a:pPr algn="l">
+              <a:defRPr sz="3450" b="1">
+                <a:solidFill>
+                  <a:srgbClr val="111111"/>
+                </a:solidFill>
+                <a:latin typeface="에스코어 드림 5 Medium"/>
+                <a:ea typeface="에스코어 드림 5 Medium"/>
+                <a:cs typeface="에스코어 드림 5 Medium"/>
+              </a:defRPr>
+            </a:pPr>
+            <a:r>
+              <a:rPr lang="ko-KR" altLang="en-US" sz="3450" b="1">
+                <a:solidFill>
+                  <a:srgbClr val="111111"/>
+                </a:solidFill>
+                <a:latin typeface="에스코어 드림 5 Medium"/>
+                <a:ea typeface="에스코어 드림 5 Medium"/>
+                <a:cs typeface="에스코어 드림 5 Medium"/>
+              </a:rPr>
+              <a:t>팀은 네 단계만 기억하면 됩니다</a:t>
+            </a:r>
+          </a:p>
+        </p:txBody>
+      </p:sp>
+      <p:sp>
+        <p:nvSpPr>
+          <p:cNvPr id="3" name="직사각형 2">
+            <a:extLst>
+              <a:ext uri="{FF2B5EF4-FFF2-40B4-BE49-F238E27FC236}">
+                <a16:creationId xmlns:a16="http://schemas.microsoft.com/office/drawing/2014/main" id="{9FEA1835-074C-44CD-AECC-606AD36EEC6F}"/>
+              </a:ext>
+            </a:extLst>
+          </p:cNvPr>
+          <p:cNvSpPr>
+            <a:spLocks noGrp="1"/>
+          </p:cNvSpPr>
+          <p:nvPr/>
+        </p:nvSpPr>
+        <p:spPr>
+          <a:xfrm>
+            <a:off x="11296650" y="6324600"/>
+            <a:ext cx="495300" cy="228600"/>
+          </a:xfrm>
+          <a:prstGeom prst="rect">
+            <a:avLst/>
+          </a:prstGeom>
+          <a:noFill/>
+          <a:ln w="0">
+            <a:noFill/>
+            <a:prstDash val="solid"/>
+          </a:ln>
+        </p:spPr>
+        <p:txBody>
+          <a:bodyPr wrap="square" lIns="0" tIns="0" rIns="0" bIns="0" anchor="t">
+            <a:normAutofit/>
+          </a:bodyPr>
+          <a:lstStyle/>
+          <a:p>
+            <a:pPr algn="r">
+              <a:defRPr sz="1050" b="0">
+                <a:solidFill>
+                  <a:srgbClr val="8A8D91"/>
+                </a:solidFill>
+                <a:latin typeface="에스코어 드림 5 Medium"/>
+                <a:ea typeface="에스코어 드림 5 Medium"/>
+                <a:cs typeface="에스코어 드림 5 Medium"/>
+              </a:defRPr>
+            </a:pPr>
+            <a:r>
+              <a:rPr lang="en-US" altLang="ko-KR" sz="1050" b="0">
+                <a:solidFill>
+                  <a:srgbClr val="8A8D91"/>
+                </a:solidFill>
+                <a:latin typeface="에스코어 드림 5 Medium"/>
+                <a:ea typeface="에스코어 드림 5 Medium"/>
+                <a:cs typeface="에스코어 드림 5 Medium"/>
+              </a:rPr>
+              <a:t>13</a:t>
+            </a:r>
+          </a:p>
+        </p:txBody>
+      </p:sp>
+      <p:sp>
+        <p:nvSpPr>
+          <p:cNvPr id="4" name="타원 3">
+            <a:extLst>
+              <a:ext uri="{FF2B5EF4-FFF2-40B4-BE49-F238E27FC236}">
+                <a16:creationId xmlns:a16="http://schemas.microsoft.com/office/drawing/2014/main" id="{FA783CAA-05EF-4059-8E67-84EB21D3E06C}"/>
+              </a:ext>
+            </a:extLst>
+          </p:cNvPr>
+          <p:cNvSpPr>
+            <a:spLocks noGrp="1"/>
+          </p:cNvSpPr>
+          <p:nvPr/>
+        </p:nvSpPr>
+        <p:spPr>
+          <a:xfrm>
+            <a:off x="571500" y="1733550"/>
+            <a:ext cx="609600" cy="609600"/>
+          </a:xfrm>
+          <a:prstGeom prst="ellipse">
+            <a:avLst/>
+          </a:prstGeom>
+          <a:solidFill>
+            <a:srgbClr val="111111"/>
+          </a:solidFill>
+          <a:ln w="9525">
+            <a:solidFill>
+              <a:srgbClr val="111111"/>
+            </a:solidFill>
+            <a:prstDash val="solid"/>
+          </a:ln>
+        </p:spPr>
+        <p:txBody>
+          <a:bodyPr/>
+          <a:lstStyle/>
+          <a:p>
+            <a:endParaRPr lang="ko-KR" altLang="en-US"/>
+          </a:p>
+        </p:txBody>
+      </p:sp>
+      <p:sp>
+        <p:nvSpPr>
+          <p:cNvPr id="5" name="직사각형 4">
+            <a:extLst>
+              <a:ext uri="{FF2B5EF4-FFF2-40B4-BE49-F238E27FC236}">
+                <a16:creationId xmlns:a16="http://schemas.microsoft.com/office/drawing/2014/main" id="{9EF3961E-086E-46D0-ABEA-EA3EFD588D5E}"/>
+              </a:ext>
+            </a:extLst>
+          </p:cNvPr>
+          <p:cNvSpPr>
+            <a:spLocks noGrp="1"/>
+          </p:cNvSpPr>
+          <p:nvPr/>
+        </p:nvSpPr>
+        <p:spPr>
+          <a:xfrm>
+            <a:off x="571500" y="1924192"/>
+            <a:ext cx="609600" cy="267645"/>
+          </a:xfrm>
+          <a:prstGeom prst="rect">
+            <a:avLst/>
+          </a:prstGeom>
+          <a:noFill/>
+          <a:ln w="0">
+            <a:noFill/>
+            <a:prstDash val="solid"/>
+          </a:ln>
+        </p:spPr>
+        <p:txBody>
+          <a:bodyPr wrap="square" lIns="0" tIns="0" rIns="0" bIns="0" anchor="t">
+            <a:normAutofit/>
+          </a:bodyPr>
+          <a:lstStyle/>
+          <a:p>
+            <a:pPr algn="ctr">
+              <a:defRPr sz="1650" b="1">
+                <a:solidFill>
+                  <a:srgbClr val="FFFFFF"/>
+                </a:solidFill>
+                <a:latin typeface="에스코어 드림 5 Medium"/>
+                <a:ea typeface="에스코어 드림 5 Medium"/>
+                <a:cs typeface="에스코어 드림 5 Medium"/>
+              </a:defRPr>
+            </a:pPr>
+            <a:r>
+              <a:rPr lang="en-US" altLang="ko-KR" sz="1650" b="1" dirty="0">
+                <a:solidFill>
+                  <a:srgbClr val="FFFFFF"/>
+                </a:solidFill>
+                <a:latin typeface="에스코어 드림 5 Medium"/>
+                <a:ea typeface="에스코어 드림 5 Medium"/>
+                <a:cs typeface="에스코어 드림 5 Medium"/>
+              </a:rPr>
+              <a:t>1</a:t>
+            </a:r>
+          </a:p>
+        </p:txBody>
+      </p:sp>
+      <p:sp>
+        <p:nvSpPr>
+          <p:cNvPr id="6" name="직사각형 5">
+            <a:extLst>
+              <a:ext uri="{FF2B5EF4-FFF2-40B4-BE49-F238E27FC236}">
+                <a16:creationId xmlns:a16="http://schemas.microsoft.com/office/drawing/2014/main" id="{3F414D70-12C4-4023-8483-C79D0F14608E}"/>
+              </a:ext>
+            </a:extLst>
+          </p:cNvPr>
+          <p:cNvSpPr>
+            <a:spLocks noGrp="1"/>
+          </p:cNvSpPr>
+          <p:nvPr/>
+        </p:nvSpPr>
+        <p:spPr>
+          <a:xfrm>
+            <a:off x="1504950" y="1714500"/>
+            <a:ext cx="4000500" cy="419100"/>
+          </a:xfrm>
+          <a:prstGeom prst="rect">
+            <a:avLst/>
+          </a:prstGeom>
+          <a:noFill/>
+          <a:ln w="0">
+            <a:noFill/>
+            <a:prstDash val="solid"/>
+          </a:ln>
+        </p:spPr>
+        <p:txBody>
+          <a:bodyPr wrap="square" lIns="0" tIns="0" rIns="0" bIns="0" anchor="t">
+            <a:normAutofit/>
+          </a:bodyPr>
+          <a:lstStyle/>
+          <a:p>
+            <a:pPr algn="l">
+              <a:defRPr sz="2025" b="1">
+                <a:solidFill>
+                  <a:srgbClr val="111111"/>
+                </a:solidFill>
+                <a:latin typeface="에스코어 드림 5 Medium"/>
+                <a:ea typeface="에스코어 드림 5 Medium"/>
+                <a:cs typeface="에스코어 드림 5 Medium"/>
+              </a:defRPr>
+            </a:pPr>
+            <a:r>
+              <a:rPr lang="ko-KR" altLang="en-US" sz="2025" b="1">
+                <a:solidFill>
+                  <a:srgbClr val="111111"/>
+                </a:solidFill>
+                <a:latin typeface="에스코어 드림 5 Medium"/>
+                <a:ea typeface="에스코어 드림 5 Medium"/>
+                <a:cs typeface="에스코어 드림 5 Medium"/>
+              </a:rPr>
+              <a:t>항상 </a:t>
+            </a:r>
+            <a:r>
+              <a:rPr lang="en-US" altLang="ko-KR" sz="2025" b="1">
+                <a:solidFill>
+                  <a:srgbClr val="111111"/>
+                </a:solidFill>
+                <a:latin typeface="에스코어 드림 5 Medium"/>
+                <a:ea typeface="에스코어 드림 5 Medium"/>
+                <a:cs typeface="에스코어 드림 5 Medium"/>
+              </a:rPr>
+              <a:t>index.md</a:t>
+            </a:r>
+            <a:r>
+              <a:rPr lang="ko-KR" altLang="en-US" sz="2025" b="1">
+                <a:solidFill>
+                  <a:srgbClr val="111111"/>
+                </a:solidFill>
+                <a:latin typeface="에스코어 드림 5 Medium"/>
+                <a:ea typeface="에스코어 드림 5 Medium"/>
+                <a:cs typeface="에스코어 드림 5 Medium"/>
+              </a:rPr>
+              <a:t>에서 시작</a:t>
+            </a:r>
+          </a:p>
+        </p:txBody>
+      </p:sp>
+      <p:sp>
+        <p:nvSpPr>
+          <p:cNvPr id="7" name="직사각형 6">
+            <a:extLst>
+              <a:ext uri="{FF2B5EF4-FFF2-40B4-BE49-F238E27FC236}">
+                <a16:creationId xmlns:a16="http://schemas.microsoft.com/office/drawing/2014/main" id="{36E4E0E3-A99D-4143-B601-0B9576305E12}"/>
+              </a:ext>
+            </a:extLst>
+          </p:cNvPr>
+          <p:cNvSpPr>
+            <a:spLocks noGrp="1"/>
+          </p:cNvSpPr>
+          <p:nvPr/>
+        </p:nvSpPr>
+        <p:spPr>
+          <a:xfrm>
+            <a:off x="5619750" y="1733550"/>
+            <a:ext cx="5810250" cy="533400"/>
+          </a:xfrm>
+          <a:prstGeom prst="rect">
+            <a:avLst/>
+          </a:prstGeom>
+          <a:noFill/>
+          <a:ln w="0">
+            <a:noFill/>
+            <a:prstDash val="solid"/>
+          </a:ln>
+        </p:spPr>
+        <p:txBody>
+          <a:bodyPr wrap="square" lIns="0" tIns="0" rIns="0" bIns="0" anchor="ctr">
+            <a:normAutofit/>
+          </a:bodyPr>
+          <a:lstStyle/>
+          <a:p>
+            <a:pPr algn="l">
+              <a:defRPr sz="1575" b="0">
+                <a:solidFill>
+                  <a:srgbClr val="5F6368"/>
+                </a:solidFill>
+                <a:latin typeface="에스코어 드림 5 Medium"/>
+                <a:ea typeface="에스코어 드림 5 Medium"/>
+                <a:cs typeface="에스코어 드림 5 Medium"/>
+              </a:defRPr>
+            </a:pPr>
+            <a:r>
+              <a:rPr lang="ko-KR" altLang="en-US" sz="1575" b="0">
+                <a:solidFill>
+                  <a:srgbClr val="5F6368"/>
+                </a:solidFill>
+                <a:latin typeface="에스코어 드림 5 Medium"/>
+                <a:ea typeface="에스코어 드림 5 Medium"/>
+                <a:cs typeface="에스코어 드림 5 Medium"/>
+              </a:rPr>
+              <a:t>프로젝트 지식의 공식 입구를 하나로 통일합니다</a:t>
+            </a:r>
+            <a:r>
+              <a:rPr lang="en-US" altLang="ko-KR" sz="1575" b="0">
+                <a:solidFill>
+                  <a:srgbClr val="5F6368"/>
+                </a:solidFill>
+                <a:latin typeface="에스코어 드림 5 Medium"/>
+                <a:ea typeface="에스코어 드림 5 Medium"/>
+                <a:cs typeface="에스코어 드림 5 Medium"/>
+              </a:rPr>
+              <a:t>.</a:t>
+            </a:r>
+          </a:p>
+        </p:txBody>
+      </p:sp>
+      <p:cxnSp>
+        <p:nvCxnSpPr>
+          <p:cNvPr id="31" name="직선 화살표 연결선 30"/>
+          <p:cNvCxnSpPr/>
+          <p:nvPr/>
+        </p:nvCxnSpPr>
+        <p:spPr>
+          <a:xfrm>
+            <a:off x="876300" y="2400300"/>
+            <a:ext cx="0" cy="342900"/>
+          </a:xfrm>
+          <a:prstGeom prst="straightConnector1">
+            <a:avLst/>
+          </a:prstGeom>
+          <a:ln w="19050">
+            <a:solidFill>
+              <a:srgbClr val="DADCE0"/>
+            </a:solidFill>
+            <a:prstDash val="solid"/>
+          </a:ln>
+        </p:spPr>
+      </p:cxnSp>
+      <p:sp>
+        <p:nvSpPr>
+          <p:cNvPr id="9" name="타원 8">
+            <a:extLst>
+              <a:ext uri="{FF2B5EF4-FFF2-40B4-BE49-F238E27FC236}">
+                <a16:creationId xmlns:a16="http://schemas.microsoft.com/office/drawing/2014/main" id="{066ACBC1-FE7C-48AA-9DCB-6511520E3F76}"/>
+              </a:ext>
+            </a:extLst>
+          </p:cNvPr>
+          <p:cNvSpPr>
+            <a:spLocks noGrp="1"/>
+          </p:cNvSpPr>
+          <p:nvPr/>
+        </p:nvSpPr>
+        <p:spPr>
+          <a:xfrm>
+            <a:off x="571500" y="2781300"/>
+            <a:ext cx="609600" cy="609600"/>
+          </a:xfrm>
+          <a:prstGeom prst="ellipse">
+            <a:avLst/>
+          </a:prstGeom>
+          <a:solidFill>
+            <a:srgbClr val="111111"/>
+          </a:solidFill>
+          <a:ln w="9525">
+            <a:solidFill>
+              <a:srgbClr val="111111"/>
+            </a:solidFill>
+            <a:prstDash val="solid"/>
+          </a:ln>
+        </p:spPr>
+        <p:txBody>
+          <a:bodyPr/>
+          <a:lstStyle/>
+          <a:p>
+            <a:endParaRPr lang="ko-KR" altLang="en-US"/>
+          </a:p>
+        </p:txBody>
+      </p:sp>
+      <p:sp>
+        <p:nvSpPr>
+          <p:cNvPr id="10" name="직사각형 9">
+            <a:extLst>
+              <a:ext uri="{FF2B5EF4-FFF2-40B4-BE49-F238E27FC236}">
+                <a16:creationId xmlns:a16="http://schemas.microsoft.com/office/drawing/2014/main" id="{B6C344BF-399F-4E0E-B0CE-67E78C03AE02}"/>
+              </a:ext>
+            </a:extLst>
+          </p:cNvPr>
+          <p:cNvSpPr>
+            <a:spLocks noGrp="1"/>
+          </p:cNvSpPr>
+          <p:nvPr/>
+        </p:nvSpPr>
+        <p:spPr>
+          <a:xfrm>
+            <a:off x="571500" y="2971942"/>
+            <a:ext cx="609600" cy="267645"/>
+          </a:xfrm>
+          <a:prstGeom prst="rect">
+            <a:avLst/>
+          </a:prstGeom>
+          <a:noFill/>
+          <a:ln w="0">
+            <a:noFill/>
+            <a:prstDash val="solid"/>
+          </a:ln>
+        </p:spPr>
+        <p:txBody>
+          <a:bodyPr wrap="square" lIns="0" tIns="0" rIns="0" bIns="0" anchor="t">
+            <a:normAutofit/>
+          </a:bodyPr>
+          <a:lstStyle/>
+          <a:p>
+            <a:pPr algn="ctr">
+              <a:defRPr sz="1650" b="1">
+                <a:solidFill>
+                  <a:srgbClr val="FFFFFF"/>
+                </a:solidFill>
+                <a:latin typeface="에스코어 드림 5 Medium"/>
+                <a:ea typeface="에스코어 드림 5 Medium"/>
+                <a:cs typeface="에스코어 드림 5 Medium"/>
+              </a:defRPr>
+            </a:pPr>
+            <a:r>
+              <a:rPr lang="en-US" altLang="ko-KR" sz="1650" b="1">
+                <a:solidFill>
+                  <a:srgbClr val="FFFFFF"/>
+                </a:solidFill>
+                <a:latin typeface="에스코어 드림 5 Medium"/>
+                <a:ea typeface="에스코어 드림 5 Medium"/>
+                <a:cs typeface="에스코어 드림 5 Medium"/>
+              </a:rPr>
+              <a:t>2</a:t>
+            </a:r>
+          </a:p>
+        </p:txBody>
+      </p:sp>
+      <p:sp>
+        <p:nvSpPr>
+          <p:cNvPr id="11" name="직사각형 10">
+            <a:extLst>
+              <a:ext uri="{FF2B5EF4-FFF2-40B4-BE49-F238E27FC236}">
+                <a16:creationId xmlns:a16="http://schemas.microsoft.com/office/drawing/2014/main" id="{B76AC60E-3818-4DD2-AA2A-809BD055D3FB}"/>
+              </a:ext>
+            </a:extLst>
+          </p:cNvPr>
+          <p:cNvSpPr>
+            <a:spLocks noGrp="1"/>
+          </p:cNvSpPr>
+          <p:nvPr/>
+        </p:nvSpPr>
+        <p:spPr>
+          <a:xfrm>
+            <a:off x="1504950" y="2762250"/>
+            <a:ext cx="4000500" cy="419100"/>
+          </a:xfrm>
+          <a:prstGeom prst="rect">
+            <a:avLst/>
+          </a:prstGeom>
+          <a:noFill/>
+          <a:ln w="0">
+            <a:noFill/>
+            <a:prstDash val="solid"/>
+          </a:ln>
+        </p:spPr>
+        <p:txBody>
+          <a:bodyPr wrap="square" lIns="0" tIns="0" rIns="0" bIns="0" anchor="t">
+            <a:normAutofit/>
+          </a:bodyPr>
+          <a:lstStyle/>
+          <a:p>
+            <a:pPr algn="l">
+              <a:defRPr sz="2025" b="1">
+                <a:solidFill>
+                  <a:srgbClr val="111111"/>
+                </a:solidFill>
+                <a:latin typeface="에스코어 드림 5 Medium"/>
+                <a:ea typeface="에스코어 드림 5 Medium"/>
+                <a:cs typeface="에스코어 드림 5 Medium"/>
+              </a:defRPr>
+            </a:pPr>
+            <a:r>
+              <a:rPr lang="ko-KR" altLang="en-US" sz="2025" b="1">
+                <a:solidFill>
+                  <a:srgbClr val="111111"/>
+                </a:solidFill>
+                <a:latin typeface="에스코어 드림 5 Medium"/>
+                <a:ea typeface="에스코어 드림 5 Medium"/>
+                <a:cs typeface="에스코어 드림 5 Medium"/>
+              </a:rPr>
+              <a:t>설명보다 근거를 확인</a:t>
+            </a:r>
+          </a:p>
+        </p:txBody>
+      </p:sp>
+      <p:sp>
+        <p:nvSpPr>
+          <p:cNvPr id="12" name="직사각형 11">
+            <a:extLst>
+              <a:ext uri="{FF2B5EF4-FFF2-40B4-BE49-F238E27FC236}">
+                <a16:creationId xmlns:a16="http://schemas.microsoft.com/office/drawing/2014/main" id="{C7A9511D-3157-485A-9CE0-97710E488CCF}"/>
+              </a:ext>
+            </a:extLst>
+          </p:cNvPr>
+          <p:cNvSpPr>
+            <a:spLocks noGrp="1"/>
+          </p:cNvSpPr>
+          <p:nvPr/>
+        </p:nvSpPr>
+        <p:spPr>
+          <a:xfrm>
+            <a:off x="5619750" y="2781300"/>
+            <a:ext cx="5810250" cy="533400"/>
+          </a:xfrm>
+          <a:prstGeom prst="rect">
+            <a:avLst/>
+          </a:prstGeom>
+          <a:noFill/>
+          <a:ln w="0">
+            <a:noFill/>
+            <a:prstDash val="solid"/>
+          </a:ln>
+        </p:spPr>
+        <p:txBody>
+          <a:bodyPr wrap="square" lIns="0" tIns="0" rIns="0" bIns="0" anchor="ctr">
+            <a:normAutofit/>
+          </a:bodyPr>
+          <a:lstStyle/>
+          <a:p>
+            <a:pPr algn="l">
+              <a:defRPr sz="1575" b="0">
+                <a:solidFill>
+                  <a:srgbClr val="5F6368"/>
+                </a:solidFill>
+                <a:latin typeface="에스코어 드림 5 Medium"/>
+                <a:ea typeface="에스코어 드림 5 Medium"/>
+                <a:cs typeface="에스코어 드림 5 Medium"/>
+              </a:defRPr>
+            </a:pPr>
+            <a:r>
+              <a:rPr lang="ko-KR" altLang="en-US" sz="1575" b="0">
+                <a:solidFill>
+                  <a:srgbClr val="5F6368"/>
+                </a:solidFill>
+                <a:latin typeface="에스코어 드림 5 Medium"/>
+                <a:ea typeface="에스코어 드림 5 Medium"/>
+                <a:cs typeface="에스코어 드림 5 Medium"/>
+              </a:rPr>
+              <a:t>문서의 </a:t>
+            </a:r>
+            <a:r>
+              <a:rPr lang="en-US" altLang="ko-KR" sz="1575" b="0">
+                <a:solidFill>
+                  <a:srgbClr val="5F6368"/>
+                </a:solidFill>
+                <a:latin typeface="에스코어 드림 5 Medium"/>
+                <a:ea typeface="에스코어 드림 5 Medium"/>
+                <a:cs typeface="에스코어 드림 5 Medium"/>
+              </a:rPr>
+              <a:t>source_files</a:t>
+            </a:r>
+            <a:r>
+              <a:rPr lang="ko-KR" altLang="en-US" sz="1575" b="0">
+                <a:solidFill>
+                  <a:srgbClr val="5F6368"/>
+                </a:solidFill>
+                <a:latin typeface="에스코어 드림 5 Medium"/>
+                <a:ea typeface="에스코어 드림 5 Medium"/>
+                <a:cs typeface="에스코어 드림 5 Medium"/>
+              </a:rPr>
+              <a:t>와 </a:t>
+            </a:r>
+            <a:r>
+              <a:rPr lang="en-US" altLang="ko-KR" sz="1575" b="0">
+                <a:solidFill>
+                  <a:srgbClr val="5F6368"/>
+                </a:solidFill>
+                <a:latin typeface="에스코어 드림 5 Medium"/>
+                <a:ea typeface="에스코어 드림 5 Medium"/>
+                <a:cs typeface="에스코어 드림 5 Medium"/>
+              </a:rPr>
+              <a:t>evidence</a:t>
+            </a:r>
+            <a:r>
+              <a:rPr lang="ko-KR" altLang="en-US" sz="1575" b="0">
+                <a:solidFill>
+                  <a:srgbClr val="5F6368"/>
+                </a:solidFill>
+                <a:latin typeface="에스코어 드림 5 Medium"/>
+                <a:ea typeface="에스코어 드림 5 Medium"/>
+                <a:cs typeface="에스코어 드림 5 Medium"/>
+              </a:rPr>
+              <a:t>를 실제 코드와 대조합니다</a:t>
+            </a:r>
+            <a:r>
+              <a:rPr lang="en-US" altLang="ko-KR" sz="1575" b="0">
+                <a:solidFill>
+                  <a:srgbClr val="5F6368"/>
+                </a:solidFill>
+                <a:latin typeface="에스코어 드림 5 Medium"/>
+                <a:ea typeface="에스코어 드림 5 Medium"/>
+                <a:cs typeface="에스코어 드림 5 Medium"/>
+              </a:rPr>
+              <a:t>.</a:t>
+            </a:r>
+          </a:p>
+        </p:txBody>
+      </p:sp>
+      <p:cxnSp>
+        <p:nvCxnSpPr>
+          <p:cNvPr id="36" name="직선 화살표 연결선 35"/>
+          <p:cNvCxnSpPr/>
+          <p:nvPr/>
+        </p:nvCxnSpPr>
+        <p:spPr>
+          <a:xfrm>
+            <a:off x="876300" y="3448050"/>
+            <a:ext cx="0" cy="342900"/>
+          </a:xfrm>
+          <a:prstGeom prst="straightConnector1">
+            <a:avLst/>
+          </a:prstGeom>
+          <a:ln w="19050">
+            <a:solidFill>
+              <a:srgbClr val="DADCE0"/>
+            </a:solidFill>
+            <a:prstDash val="solid"/>
+          </a:ln>
+        </p:spPr>
+      </p:cxnSp>
+      <p:sp>
+        <p:nvSpPr>
+          <p:cNvPr id="14" name="타원 13">
+            <a:extLst>
+              <a:ext uri="{FF2B5EF4-FFF2-40B4-BE49-F238E27FC236}">
+                <a16:creationId xmlns:a16="http://schemas.microsoft.com/office/drawing/2014/main" id="{10EDA4C5-E48D-42F6-8627-63BCCF7D4B16}"/>
+              </a:ext>
+            </a:extLst>
+          </p:cNvPr>
+          <p:cNvSpPr>
+            <a:spLocks noGrp="1"/>
+          </p:cNvSpPr>
+          <p:nvPr/>
+        </p:nvSpPr>
+        <p:spPr>
+          <a:xfrm>
+            <a:off x="571500" y="3829050"/>
+            <a:ext cx="609600" cy="609600"/>
+          </a:xfrm>
+          <a:prstGeom prst="ellipse">
+            <a:avLst/>
+          </a:prstGeom>
+          <a:solidFill>
+            <a:srgbClr val="111111"/>
+          </a:solidFill>
+          <a:ln w="9525">
+            <a:solidFill>
+              <a:srgbClr val="111111"/>
+            </a:solidFill>
+            <a:prstDash val="solid"/>
+          </a:ln>
+        </p:spPr>
+        <p:txBody>
+          <a:bodyPr/>
+          <a:lstStyle/>
+          <a:p>
+            <a:endParaRPr lang="ko-KR" altLang="en-US"/>
+          </a:p>
+        </p:txBody>
+      </p:sp>
+      <p:sp>
+        <p:nvSpPr>
+          <p:cNvPr id="15" name="직사각형 14">
+            <a:extLst>
+              <a:ext uri="{FF2B5EF4-FFF2-40B4-BE49-F238E27FC236}">
+                <a16:creationId xmlns:a16="http://schemas.microsoft.com/office/drawing/2014/main" id="{1E7970CC-D970-4999-8704-9373BD8EEC86}"/>
+              </a:ext>
+            </a:extLst>
+          </p:cNvPr>
+          <p:cNvSpPr>
+            <a:spLocks noGrp="1"/>
+          </p:cNvSpPr>
+          <p:nvPr/>
+        </p:nvSpPr>
+        <p:spPr>
+          <a:xfrm>
+            <a:off x="571500" y="4019692"/>
+            <a:ext cx="609600" cy="267645"/>
+          </a:xfrm>
+          <a:prstGeom prst="rect">
+            <a:avLst/>
+          </a:prstGeom>
+          <a:noFill/>
+          <a:ln w="0">
+            <a:noFill/>
+            <a:prstDash val="solid"/>
+          </a:ln>
+        </p:spPr>
+        <p:txBody>
+          <a:bodyPr wrap="square" lIns="0" tIns="0" rIns="0" bIns="0" anchor="t">
+            <a:normAutofit/>
+          </a:bodyPr>
+          <a:lstStyle/>
+          <a:p>
+            <a:pPr algn="ctr">
+              <a:defRPr sz="1650" b="1">
+                <a:solidFill>
+                  <a:srgbClr val="FFFFFF"/>
+                </a:solidFill>
+                <a:latin typeface="에스코어 드림 5 Medium"/>
+                <a:ea typeface="에스코어 드림 5 Medium"/>
+                <a:cs typeface="에스코어 드림 5 Medium"/>
+              </a:defRPr>
+            </a:pPr>
+            <a:r>
+              <a:rPr lang="en-US" altLang="ko-KR" sz="1650" b="1">
+                <a:solidFill>
+                  <a:srgbClr val="FFFFFF"/>
+                </a:solidFill>
+                <a:latin typeface="에스코어 드림 5 Medium"/>
+                <a:ea typeface="에스코어 드림 5 Medium"/>
+                <a:cs typeface="에스코어 드림 5 Medium"/>
+              </a:rPr>
+              <a:t>3</a:t>
+            </a:r>
+          </a:p>
+        </p:txBody>
+      </p:sp>
+      <p:sp>
+        <p:nvSpPr>
+          <p:cNvPr id="16" name="직사각형 15">
+            <a:extLst>
+              <a:ext uri="{FF2B5EF4-FFF2-40B4-BE49-F238E27FC236}">
+                <a16:creationId xmlns:a16="http://schemas.microsoft.com/office/drawing/2014/main" id="{1AF24252-A158-4A4F-B5EB-47D8FDFB9546}"/>
+              </a:ext>
+            </a:extLst>
+          </p:cNvPr>
+          <p:cNvSpPr>
+            <a:spLocks noGrp="1"/>
+          </p:cNvSpPr>
+          <p:nvPr/>
+        </p:nvSpPr>
+        <p:spPr>
+          <a:xfrm>
+            <a:off x="1504950" y="3810000"/>
+            <a:ext cx="4000500" cy="419100"/>
+          </a:xfrm>
+          <a:prstGeom prst="rect">
+            <a:avLst/>
+          </a:prstGeom>
+          <a:noFill/>
+          <a:ln w="0">
+            <a:noFill/>
+            <a:prstDash val="solid"/>
+          </a:ln>
+        </p:spPr>
+        <p:txBody>
+          <a:bodyPr wrap="square" lIns="0" tIns="0" rIns="0" bIns="0" anchor="t">
+            <a:normAutofit/>
+          </a:bodyPr>
+          <a:lstStyle/>
+          <a:p>
+            <a:pPr algn="l">
+              <a:defRPr sz="2025" b="1">
+                <a:solidFill>
+                  <a:srgbClr val="111111"/>
+                </a:solidFill>
+                <a:latin typeface="에스코어 드림 5 Medium"/>
+                <a:ea typeface="에스코어 드림 5 Medium"/>
+                <a:cs typeface="에스코어 드림 5 Medium"/>
+              </a:defRPr>
+            </a:pPr>
+            <a:r>
+              <a:rPr lang="ko-KR" altLang="en-US" sz="2025" b="1">
+                <a:solidFill>
+                  <a:srgbClr val="111111"/>
+                </a:solidFill>
+                <a:latin typeface="에스코어 드림 5 Medium"/>
+                <a:ea typeface="에스코어 드림 5 Medium"/>
+                <a:cs typeface="에스코어 드림 5 Medium"/>
+              </a:rPr>
+              <a:t>코드와 위키를 함께 변경</a:t>
+            </a:r>
+          </a:p>
+        </p:txBody>
+      </p:sp>
+      <p:sp>
+        <p:nvSpPr>
+          <p:cNvPr id="17" name="직사각형 16">
+            <a:extLst>
+              <a:ext uri="{FF2B5EF4-FFF2-40B4-BE49-F238E27FC236}">
+                <a16:creationId xmlns:a16="http://schemas.microsoft.com/office/drawing/2014/main" id="{D6F2D7D7-9C66-4423-8A9E-16C6A905782C}"/>
+              </a:ext>
+            </a:extLst>
+          </p:cNvPr>
+          <p:cNvSpPr>
+            <a:spLocks noGrp="1"/>
+          </p:cNvSpPr>
+          <p:nvPr/>
+        </p:nvSpPr>
+        <p:spPr>
+          <a:xfrm>
+            <a:off x="5619750" y="3829050"/>
+            <a:ext cx="5810250" cy="533400"/>
+          </a:xfrm>
+          <a:prstGeom prst="rect">
+            <a:avLst/>
+          </a:prstGeom>
+          <a:noFill/>
+          <a:ln w="0">
+            <a:noFill/>
+            <a:prstDash val="solid"/>
+          </a:ln>
+        </p:spPr>
+        <p:txBody>
+          <a:bodyPr wrap="square" lIns="0" tIns="0" rIns="0" bIns="0" anchor="ctr">
+            <a:normAutofit/>
+          </a:bodyPr>
+          <a:lstStyle/>
+          <a:p>
+            <a:pPr algn="l">
+              <a:defRPr sz="1575" b="0">
+                <a:solidFill>
+                  <a:srgbClr val="5F6368"/>
+                </a:solidFill>
+                <a:latin typeface="에스코어 드림 5 Medium"/>
+                <a:ea typeface="에스코어 드림 5 Medium"/>
+                <a:cs typeface="에스코어 드림 5 Medium"/>
+              </a:defRPr>
+            </a:pPr>
+            <a:r>
+              <a:rPr lang="ko-KR" altLang="en-US" sz="1575" b="0">
+                <a:solidFill>
+                  <a:srgbClr val="5F6368"/>
+                </a:solidFill>
+                <a:latin typeface="에스코어 드림 5 Medium"/>
+                <a:ea typeface="에스코어 드림 5 Medium"/>
+                <a:cs typeface="에스코어 드림 5 Medium"/>
+              </a:rPr>
+              <a:t>기능이 바뀌면 관련 설명과 변경 로그도 같은 작업에서 갱신합니다</a:t>
+            </a:r>
+            <a:r>
+              <a:rPr lang="en-US" altLang="ko-KR" sz="1575" b="0">
+                <a:solidFill>
+                  <a:srgbClr val="5F6368"/>
+                </a:solidFill>
+                <a:latin typeface="에스코어 드림 5 Medium"/>
+                <a:ea typeface="에스코어 드림 5 Medium"/>
+                <a:cs typeface="에스코어 드림 5 Medium"/>
+              </a:rPr>
+              <a:t>.</a:t>
+            </a:r>
+          </a:p>
+        </p:txBody>
+      </p:sp>
+      <p:cxnSp>
+        <p:nvCxnSpPr>
+          <p:cNvPr id="41" name="직선 화살표 연결선 40"/>
+          <p:cNvCxnSpPr/>
+          <p:nvPr/>
+        </p:nvCxnSpPr>
+        <p:spPr>
+          <a:xfrm>
+            <a:off x="876300" y="4495800"/>
+            <a:ext cx="0" cy="342900"/>
+          </a:xfrm>
+          <a:prstGeom prst="straightConnector1">
+            <a:avLst/>
+          </a:prstGeom>
+          <a:ln w="19050">
+            <a:solidFill>
+              <a:srgbClr val="DADCE0"/>
+            </a:solidFill>
+            <a:prstDash val="solid"/>
+          </a:ln>
+        </p:spPr>
+      </p:cxnSp>
+      <p:sp>
+        <p:nvSpPr>
+          <p:cNvPr id="19" name="타원 18">
+            <a:extLst>
+              <a:ext uri="{FF2B5EF4-FFF2-40B4-BE49-F238E27FC236}">
+                <a16:creationId xmlns:a16="http://schemas.microsoft.com/office/drawing/2014/main" id="{ACCEC513-8C8F-4C00-9E73-08B6D13F2D1C}"/>
+              </a:ext>
+            </a:extLst>
+          </p:cNvPr>
+          <p:cNvSpPr>
+            <a:spLocks noGrp="1"/>
+          </p:cNvSpPr>
+          <p:nvPr/>
+        </p:nvSpPr>
+        <p:spPr>
+          <a:xfrm>
+            <a:off x="571500" y="4876800"/>
+            <a:ext cx="609600" cy="609600"/>
+          </a:xfrm>
+          <a:prstGeom prst="ellipse">
+            <a:avLst/>
+          </a:prstGeom>
+          <a:solidFill>
+            <a:srgbClr val="2563EB"/>
+          </a:solidFill>
+          <a:ln w="9525">
+            <a:solidFill>
+              <a:srgbClr val="2563EB"/>
+            </a:solidFill>
+            <a:prstDash val="solid"/>
+          </a:ln>
+        </p:spPr>
+        <p:txBody>
+          <a:bodyPr/>
+          <a:lstStyle/>
+          <a:p>
+            <a:endParaRPr lang="ko-KR" altLang="en-US"/>
+          </a:p>
+        </p:txBody>
+      </p:sp>
+      <p:sp>
+        <p:nvSpPr>
+          <p:cNvPr id="20" name="직사각형 19">
+            <a:extLst>
+              <a:ext uri="{FF2B5EF4-FFF2-40B4-BE49-F238E27FC236}">
+                <a16:creationId xmlns:a16="http://schemas.microsoft.com/office/drawing/2014/main" id="{D7AB8B56-B291-4C41-B0D6-2D8B4D9DAE64}"/>
+              </a:ext>
+            </a:extLst>
+          </p:cNvPr>
+          <p:cNvSpPr>
+            <a:spLocks noGrp="1"/>
+          </p:cNvSpPr>
+          <p:nvPr/>
+        </p:nvSpPr>
+        <p:spPr>
+          <a:xfrm>
+            <a:off x="571500" y="5067442"/>
+            <a:ext cx="609600" cy="267645"/>
+          </a:xfrm>
+          <a:prstGeom prst="rect">
+            <a:avLst/>
+          </a:prstGeom>
+          <a:noFill/>
+          <a:ln w="0">
+            <a:noFill/>
+            <a:prstDash val="solid"/>
+          </a:ln>
+        </p:spPr>
+        <p:txBody>
+          <a:bodyPr wrap="square" lIns="0" tIns="0" rIns="0" bIns="0" anchor="t">
+            <a:normAutofit/>
+          </a:bodyPr>
+          <a:lstStyle/>
+          <a:p>
+            <a:pPr algn="ctr">
+              <a:defRPr sz="1650" b="1">
+                <a:solidFill>
+                  <a:srgbClr val="FFFFFF"/>
+                </a:solidFill>
+                <a:latin typeface="에스코어 드림 5 Medium"/>
+                <a:ea typeface="에스코어 드림 5 Medium"/>
+                <a:cs typeface="에스코어 드림 5 Medium"/>
+              </a:defRPr>
+            </a:pPr>
+            <a:r>
+              <a:rPr lang="en-US" altLang="ko-KR" sz="1650" b="1">
+                <a:solidFill>
+                  <a:srgbClr val="FFFFFF"/>
+                </a:solidFill>
+                <a:latin typeface="에스코어 드림 5 Medium"/>
+                <a:ea typeface="에스코어 드림 5 Medium"/>
+                <a:cs typeface="에스코어 드림 5 Medium"/>
+              </a:rPr>
+              <a:t>4</a:t>
+            </a:r>
+          </a:p>
+        </p:txBody>
+      </p:sp>
+      <p:sp>
+        <p:nvSpPr>
+          <p:cNvPr id="21" name="직사각형 20">
+            <a:extLst>
+              <a:ext uri="{FF2B5EF4-FFF2-40B4-BE49-F238E27FC236}">
+                <a16:creationId xmlns:a16="http://schemas.microsoft.com/office/drawing/2014/main" id="{26A34BAF-9F07-4325-969D-73EC36FC7FAC}"/>
+              </a:ext>
+            </a:extLst>
+          </p:cNvPr>
+          <p:cNvSpPr>
+            <a:spLocks noGrp="1"/>
+          </p:cNvSpPr>
+          <p:nvPr/>
+        </p:nvSpPr>
+        <p:spPr>
+          <a:xfrm>
+            <a:off x="1504950" y="4857750"/>
+            <a:ext cx="4000500" cy="419100"/>
+          </a:xfrm>
+          <a:prstGeom prst="rect">
+            <a:avLst/>
+          </a:prstGeom>
+          <a:noFill/>
+          <a:ln w="0">
+            <a:noFill/>
+            <a:prstDash val="solid"/>
+          </a:ln>
+        </p:spPr>
+        <p:txBody>
+          <a:bodyPr wrap="square" lIns="0" tIns="0" rIns="0" bIns="0" anchor="t">
+            <a:normAutofit/>
+          </a:bodyPr>
+          <a:lstStyle/>
+          <a:p>
+            <a:pPr algn="l">
+              <a:defRPr sz="2025" b="1">
+                <a:solidFill>
+                  <a:srgbClr val="111111"/>
+                </a:solidFill>
+                <a:latin typeface="에스코어 드림 5 Medium"/>
+                <a:ea typeface="에스코어 드림 5 Medium"/>
+                <a:cs typeface="에스코어 드림 5 Medium"/>
+              </a:defRPr>
+            </a:pPr>
+            <a:r>
+              <a:rPr lang="ko-KR" altLang="en-US" sz="2025" b="1">
+                <a:solidFill>
+                  <a:srgbClr val="111111"/>
+                </a:solidFill>
+                <a:latin typeface="에스코어 드림 5 Medium"/>
+                <a:ea typeface="에스코어 드림 5 Medium"/>
+                <a:cs typeface="에스코어 드림 5 Medium"/>
+              </a:rPr>
+              <a:t>사람이 마지막 도장을 찍기</a:t>
+            </a:r>
+          </a:p>
+        </p:txBody>
+      </p:sp>
+      <p:sp>
+        <p:nvSpPr>
+          <p:cNvPr id="22" name="직사각형 21">
+            <a:extLst>
+              <a:ext uri="{FF2B5EF4-FFF2-40B4-BE49-F238E27FC236}">
+                <a16:creationId xmlns:a16="http://schemas.microsoft.com/office/drawing/2014/main" id="{FFD73BD0-EB19-4246-BB9B-F9BFC5A7DFD6}"/>
+              </a:ext>
+            </a:extLst>
+          </p:cNvPr>
+          <p:cNvSpPr>
+            <a:spLocks noGrp="1"/>
+          </p:cNvSpPr>
+          <p:nvPr/>
+        </p:nvSpPr>
+        <p:spPr>
+          <a:xfrm>
+            <a:off x="5619750" y="4876800"/>
+            <a:ext cx="5810250" cy="533400"/>
+          </a:xfrm>
+          <a:prstGeom prst="rect">
+            <a:avLst/>
+          </a:prstGeom>
+          <a:noFill/>
+          <a:ln w="0">
+            <a:noFill/>
+            <a:prstDash val="solid"/>
+          </a:ln>
+        </p:spPr>
+        <p:txBody>
+          <a:bodyPr wrap="square" lIns="0" tIns="0" rIns="0" bIns="0" anchor="ctr">
+            <a:normAutofit/>
+          </a:bodyPr>
+          <a:lstStyle/>
+          <a:p>
+            <a:pPr algn="l">
+              <a:defRPr sz="1575" b="0">
+                <a:solidFill>
+                  <a:srgbClr val="5F6368"/>
+                </a:solidFill>
+                <a:latin typeface="에스코어 드림 5 Medium"/>
+                <a:ea typeface="에스코어 드림 5 Medium"/>
+                <a:cs typeface="에스코어 드림 5 Medium"/>
+              </a:defRPr>
+            </a:pPr>
+            <a:r>
+              <a:rPr lang="en-US" altLang="ko-KR" sz="1575" b="0">
+                <a:solidFill>
+                  <a:srgbClr val="5F6368"/>
+                </a:solidFill>
+                <a:latin typeface="에스코어 드림 5 Medium"/>
+                <a:ea typeface="에스코어 드림 5 Medium"/>
+                <a:cs typeface="에스코어 드림 5 Medium"/>
+              </a:rPr>
+              <a:t>AI </a:t>
+            </a:r>
+            <a:r>
+              <a:rPr lang="ko-KR" altLang="en-US" sz="1575" b="0">
+                <a:solidFill>
+                  <a:srgbClr val="5F6368"/>
+                </a:solidFill>
+                <a:latin typeface="에스코어 드림 5 Medium"/>
+                <a:ea typeface="에스코어 드림 5 Medium"/>
+                <a:cs typeface="에스코어 드림 5 Medium"/>
+              </a:rPr>
+              <a:t>수정본은 </a:t>
+            </a:r>
+            <a:r>
+              <a:rPr lang="en-US" altLang="ko-KR" sz="1575" b="0">
+                <a:solidFill>
+                  <a:srgbClr val="5F6368"/>
+                </a:solidFill>
+                <a:latin typeface="에스코어 드림 5 Medium"/>
+                <a:ea typeface="에스코어 드림 5 Medium"/>
+                <a:cs typeface="에스코어 드림 5 Medium"/>
+              </a:rPr>
+              <a:t>needs_review, </a:t>
+            </a:r>
+            <a:r>
+              <a:rPr lang="ko-KR" altLang="en-US" sz="1575" b="0">
+                <a:solidFill>
+                  <a:srgbClr val="5F6368"/>
+                </a:solidFill>
+                <a:latin typeface="에스코어 드림 5 Medium"/>
+                <a:ea typeface="에스코어 드림 5 Medium"/>
+                <a:cs typeface="에스코어 드림 5 Medium"/>
+              </a:rPr>
+              <a:t>확인이 끝나면 </a:t>
+            </a:r>
+            <a:r>
+              <a:rPr lang="en-US" altLang="ko-KR" sz="1575" b="0">
+                <a:solidFill>
+                  <a:srgbClr val="5F6368"/>
+                </a:solidFill>
+                <a:latin typeface="에스코어 드림 5 Medium"/>
+                <a:ea typeface="에스코어 드림 5 Medium"/>
+                <a:cs typeface="에스코어 드림 5 Medium"/>
+              </a:rPr>
+              <a:t>verified</a:t>
+            </a:r>
+            <a:r>
+              <a:rPr lang="ko-KR" altLang="en-US" sz="1575" b="0">
+                <a:solidFill>
+                  <a:srgbClr val="5F6368"/>
+                </a:solidFill>
+                <a:latin typeface="에스코어 드림 5 Medium"/>
+                <a:ea typeface="에스코어 드림 5 Medium"/>
+                <a:cs typeface="에스코어 드림 5 Medium"/>
+              </a:rPr>
+              <a:t>로 승격합니다</a:t>
+            </a:r>
+            <a:r>
+              <a:rPr lang="en-US" altLang="ko-KR" sz="1575" b="0">
+                <a:solidFill>
+                  <a:srgbClr val="5F6368"/>
+                </a:solidFill>
+                <a:latin typeface="에스코어 드림 5 Medium"/>
+                <a:ea typeface="에스코어 드림 5 Medium"/>
+                <a:cs typeface="에스코어 드림 5 Medium"/>
+              </a:rPr>
+              <a:t>.</a:t>
+            </a:r>
+          </a:p>
+        </p:txBody>
+      </p:sp>
+      <p:sp>
+        <p:nvSpPr>
+          <p:cNvPr id="23" name="직사각형 22">
+            <a:extLst>
+              <a:ext uri="{FF2B5EF4-FFF2-40B4-BE49-F238E27FC236}">
+                <a16:creationId xmlns:a16="http://schemas.microsoft.com/office/drawing/2014/main" id="{D69B8427-04B9-411A-8925-20F6F1081FC4}"/>
+              </a:ext>
+            </a:extLst>
+          </p:cNvPr>
+          <p:cNvSpPr>
+            <a:spLocks noGrp="1"/>
+          </p:cNvSpPr>
+          <p:nvPr/>
+        </p:nvSpPr>
+        <p:spPr>
+          <a:xfrm>
+            <a:off x="400050" y="6324600"/>
+            <a:ext cx="4000500" cy="228600"/>
+          </a:xfrm>
+          <a:prstGeom prst="rect">
+            <a:avLst/>
+          </a:prstGeom>
+          <a:noFill/>
+          <a:ln w="0">
+            <a:noFill/>
+            <a:prstDash val="solid"/>
+          </a:ln>
+        </p:spPr>
+        <p:txBody>
+          <a:bodyPr wrap="square" lIns="0" tIns="0" rIns="0" bIns="0" anchor="t">
+            <a:normAutofit/>
+          </a:bodyPr>
+          <a:lstStyle/>
+          <a:p>
+            <a:pPr algn="l">
+              <a:defRPr sz="1050" b="0">
+                <a:solidFill>
+                  <a:srgbClr val="8A8D91"/>
+                </a:solidFill>
+                <a:latin typeface="에스코어 드림 5 Medium"/>
+                <a:ea typeface="에스코어 드림 5 Medium"/>
+                <a:cs typeface="에스코어 드림 5 Medium"/>
+              </a:defRPr>
+            </a:pPr>
+            <a:r>
+              <a:rPr lang="ko-KR" altLang="en-US" sz="1050" b="0">
+                <a:solidFill>
+                  <a:srgbClr val="8A8D91"/>
+                </a:solidFill>
+                <a:latin typeface="에스코어 드림 5 Medium"/>
+                <a:ea typeface="에스코어 드림 5 Medium"/>
+                <a:cs typeface="에스코어 드림 5 Medium"/>
+              </a:rPr>
+              <a:t>팀 공유용 </a:t>
+            </a:r>
+            <a:r>
+              <a:rPr lang="en-US" altLang="ko-KR" sz="1050" b="0">
+                <a:solidFill>
+                  <a:srgbClr val="8A8D91"/>
+                </a:solidFill>
+                <a:latin typeface="에스코어 드림 5 Medium"/>
+                <a:ea typeface="에스코어 드림 5 Medium"/>
+                <a:cs typeface="에스코어 드림 5 Medium"/>
+              </a:rPr>
+              <a:t>· </a:t>
+            </a:r>
+            <a:r>
+              <a:rPr lang="ko-KR" altLang="en-US" sz="1050" b="0">
+                <a:solidFill>
+                  <a:srgbClr val="8A8D91"/>
+                </a:solidFill>
+                <a:latin typeface="에스코어 드림 5 Medium"/>
+                <a:ea typeface="에스코어 드림 5 Medium"/>
+                <a:cs typeface="에스코어 드림 5 Medium"/>
+              </a:rPr>
+              <a:t>내부 자료</a:t>
+            </a:r>
+          </a:p>
+        </p:txBody>
+      </p:sp>
+    </p:spTree>
+    <p:extLst>
+      <p:ext uri="{BB962C8B-B14F-4D97-AF65-F5344CB8AC3E}">
+        <p14:creationId xmlns:p14="http://schemas.microsoft.com/office/powerpoint/2010/main" val="1242275027"/>
+      </p:ext>
+    </p:extLst>
+  </p:cSld>
+  <p:clrMapOvr>
+    <a:masterClrMapping/>
+  </p:clrMapOvr>
+</p:sld>
+</file>
+
+<file path=ppt/slides/slide13.xml><?xml version="1.0" encoding="utf-8"?>
+<p:sld xmlns:a="http://schemas.openxmlformats.org/drawingml/2006/main" xmlns:r="http://schemas.openxmlformats.org/officeDocument/2006/relationships" xmlns:p="http://schemas.openxmlformats.org/presentationml/2006/main">
+  <p:cSld>
+    <p:bg>
+      <p:bgPr>
+        <a:solidFill>
+          <a:srgbClr val="FFFFFF"/>
+        </a:solidFill>
+        <a:effectLst/>
+      </p:bgPr>
+    </p:bg>
+    <p:spTree>
+      <p:nvGrpSpPr>
+        <p:cNvPr id="1" name=""/>
+        <p:cNvGrpSpPr/>
+        <p:nvPr/>
+      </p:nvGrpSpPr>
+      <p:grpSpPr>
+        <a:xfrm>
+          <a:off x="0" y="0"/>
+          <a:ext cx="0" cy="0"/>
+          <a:chOff x="0" y="0"/>
+          <a:chExt cx="0" cy="0"/>
+        </a:xfrm>
+      </p:grpSpPr>
+      <p:sp>
+        <p:nvSpPr>
           <p:cNvPr id="3" name="직사각형 2">
             <a:extLst>
               <a:ext uri="{FF2B5EF4-FFF2-40B4-BE49-F238E27FC236}">
@@ -5160,6 +5505,349 @@
         <p14:creationId xmlns:p14="http://schemas.microsoft.com/office/powerpoint/2010/main" val="943202436"/>
       </p:ext>
     </p:extLst>
+  </p:cSld>
+  <p:clrMapOvr>
+    <a:masterClrMapping/>
+  </p:clrMapOvr>
+</p:sld>
+</file>
+
+<file path=ppt/slides/slide14.xml><?xml version="1.0" encoding="utf-8"?>
+<p:sld xmlns:a="http://schemas.openxmlformats.org/drawingml/2006/main" xmlns:p="http://schemas.openxmlformats.org/presentationml/2006/main" xmlns:r="http://schemas.openxmlformats.org/officeDocument/2006/relationships">
+  <p:cSld>
+    <p:bg>
+      <p:bgPr>
+        <a:solidFill>
+          <a:srgbClr val="FFFFFF"/>
+        </a:solidFill>
+        <a:effectLst/>
+      </p:bgPr>
+    </p:bg>
+    <p:spTree>
+      <p:nvGrpSpPr>
+        <p:cNvPr id="1" name=""/>
+        <p:cNvGrpSpPr/>
+        <p:nvPr/>
+      </p:nvGrpSpPr>
+      <p:grpSpPr/>
+      <p:sp>
+        <p:nvSpPr>
+          <p:cNvPr id="15" name="직사각형 14">
+            <a:extLst>
+              <a:ext uri="{FF2B5EF4-FFF2-40B4-BE49-F238E27FC236}">
+                <a16:creationId xmlns:a16="http://schemas.microsoft.com/office/drawing/2014/main" id="{A50958BA-1905-45A5-8C34-A3CCE237DEC7}"/>
+              </a:ext>
+            </a:extLst>
+          </p:cNvPr>
+          <p:cNvSpPr>
+            <a:spLocks noGrp="1"/>
+          </p:cNvSpPr>
+          <p:nvPr/>
+        </p:nvSpPr>
+        <p:spPr>
+          <a:xfrm>
+            <a:off x="400050" y="323850"/>
+            <a:ext cx="3048000" cy="285750"/>
+          </a:xfrm>
+          <a:prstGeom prst="rect">
+            <a:avLst/>
+          </a:prstGeom>
+          <a:noFill/>
+          <a:ln w="0">
+            <a:noFill/>
+            <a:prstDash val="solid"/>
+          </a:ln>
+        </p:spPr>
+        <p:txBody>
+          <a:bodyPr wrap="square" lIns="0" tIns="0" rIns="0" bIns="0" anchor="t">
+            <a:normAutofit/>
+          </a:bodyPr>
+          <a:lstStyle/>
+          <a:p>
+            <a:pPr algn="l">
+              <a:defRPr sz="1200" b="1">
+                <a:solidFill>
+                  <a:srgbClr val="2563EB"/>
+                </a:solidFill>
+                <a:latin typeface="에스코어 드림 5 Medium"/>
+                <a:ea typeface="에스코어 드림 5 Medium"/>
+                <a:cs typeface="에스코어 드림 5 Medium"/>
+              </a:defRPr>
+            </a:pPr>
+            <a:r>
+              <a:rPr lang="en-US" sz="1200" b="1">
+                <a:solidFill>
+                  <a:srgbClr val="2563EB"/>
+                </a:solidFill>
+                <a:latin typeface="에스코어 드림 5 Medium"/>
+                <a:ea typeface="에스코어 드림 5 Medium"/>
+                <a:cs typeface="에스코어 드림 5 Medium"/>
+              </a:rPr>
+              <a:t>LLM-WIKI 1.5.1</a:t>
+            </a:r>
+          </a:p>
+        </p:txBody>
+      </p:sp>
+      <p:sp>
+        <p:nvSpPr>
+          <p:cNvPr id="2" name="직사각형 1">
+            <a:extLst>
+              <a:ext uri="{FF2B5EF4-FFF2-40B4-BE49-F238E27FC236}">
+                <a16:creationId xmlns:a16="http://schemas.microsoft.com/office/drawing/2014/main" id="{278384C7-B16A-4E1D-B257-E6E68F4B4C33}"/>
+              </a:ext>
+            </a:extLst>
+          </p:cNvPr>
+          <p:cNvSpPr>
+            <a:spLocks noGrp="1"/>
+          </p:cNvSpPr>
+          <p:nvPr/>
+        </p:nvSpPr>
+        <p:spPr>
+          <a:xfrm>
+            <a:off x="400050" y="723900"/>
+            <a:ext cx="11049000" cy="685800"/>
+          </a:xfrm>
+          <a:prstGeom prst="rect">
+            <a:avLst/>
+          </a:prstGeom>
+          <a:noFill/>
+          <a:ln w="0">
+            <a:noFill/>
+            <a:prstDash val="solid"/>
+          </a:ln>
+        </p:spPr>
+        <p:txBody>
+          <a:bodyPr wrap="square" lIns="0" tIns="0" rIns="0" bIns="0" anchor="ctr">
+            <a:normAutofit fontScale="85592"/>
+          </a:bodyPr>
+          <a:lstStyle/>
+          <a:p>
+            <a:pPr algn="l">
+              <a:defRPr sz="3450" b="1">
+                <a:solidFill>
+                  <a:srgbClr val="111111"/>
+                </a:solidFill>
+                <a:latin typeface="에스코어 드림 5 Medium"/>
+                <a:ea typeface="에스코어 드림 5 Medium"/>
+                <a:cs typeface="에스코어 드림 5 Medium"/>
+              </a:defRPr>
+            </a:pPr>
+            <a:r>
+              <a:rPr lang="ko-KR" altLang="en-US" sz="3450" b="1">
+                <a:solidFill>
+                  <a:srgbClr val="111111"/>
+                </a:solidFill>
+                <a:latin typeface="에스코어 드림 5 Medium"/>
+                <a:ea typeface="에스코어 드림 5 Medium"/>
+                <a:cs typeface="에스코어 드림 5 Medium"/>
+              </a:rPr>
+              <a:t>실제 화면: 지식 그래프 (문서 연결 지도)</a:t>
+            </a:r>
+          </a:p>
+        </p:txBody>
+      </p:sp>
+      <p:sp>
+        <p:nvSpPr>
+          <p:cNvPr id="3" name="직사각형 2">
+            <a:extLst>
+              <a:ext uri="{FF2B5EF4-FFF2-40B4-BE49-F238E27FC236}">
+                <a16:creationId xmlns:a16="http://schemas.microsoft.com/office/drawing/2014/main" id="{8E6B4BDC-6C83-4771-9772-0B1655F37A90}"/>
+              </a:ext>
+            </a:extLst>
+          </p:cNvPr>
+          <p:cNvSpPr>
+            <a:spLocks noGrp="1"/>
+          </p:cNvSpPr>
+          <p:nvPr/>
+        </p:nvSpPr>
+        <p:spPr>
+          <a:xfrm>
+            <a:off x="11296650" y="6324600"/>
+            <a:ext cx="495300" cy="228600"/>
+          </a:xfrm>
+          <a:prstGeom prst="rect">
+            <a:avLst/>
+          </a:prstGeom>
+          <a:noFill/>
+          <a:ln w="0">
+            <a:noFill/>
+            <a:prstDash val="solid"/>
+          </a:ln>
+        </p:spPr>
+        <p:txBody>
+          <a:bodyPr wrap="square" lIns="0" tIns="0" rIns="0" bIns="0" anchor="t">
+            <a:normAutofit/>
+          </a:bodyPr>
+          <a:lstStyle/>
+          <a:p>
+            <a:pPr algn="r">
+              <a:defRPr sz="1050" b="0">
+                <a:solidFill>
+                  <a:srgbClr val="8A8D91"/>
+                </a:solidFill>
+                <a:latin typeface="에스코어 드림 5 Medium"/>
+                <a:ea typeface="에스코어 드림 5 Medium"/>
+                <a:cs typeface="에스코어 드림 5 Medium"/>
+              </a:defRPr>
+            </a:pPr>
+            <a:r>
+              <a:rPr lang="en-US" altLang="ko-KR" sz="1050" b="0">
+                <a:solidFill>
+                  <a:srgbClr val="8A8D91"/>
+                </a:solidFill>
+                <a:latin typeface="에스코어 드림 5 Medium"/>
+                <a:ea typeface="에스코어 드림 5 Medium"/>
+                <a:cs typeface="에스코어 드림 5 Medium"/>
+              </a:rPr>
+              <a:t>12</a:t>
+            </a:r>
+          </a:p>
+        </p:txBody>
+      </p:sp>
+      <p:sp>
+        <p:nvSpPr>
+          <p:cNvPr id="14" name="직사각형 13">
+            <a:extLst>
+              <a:ext uri="{FF2B5EF4-FFF2-40B4-BE49-F238E27FC236}">
+                <a16:creationId xmlns:a16="http://schemas.microsoft.com/office/drawing/2014/main" id="{2CD7065B-DC54-42AB-B1CC-05DD9900677D}"/>
+              </a:ext>
+            </a:extLst>
+          </p:cNvPr>
+          <p:cNvSpPr>
+            <a:spLocks noGrp="1"/>
+          </p:cNvSpPr>
+          <p:nvPr/>
+        </p:nvSpPr>
+        <p:spPr>
+          <a:xfrm>
+            <a:off x="400050" y="6324600"/>
+            <a:ext cx="4000500" cy="228600"/>
+          </a:xfrm>
+          <a:prstGeom prst="rect">
+            <a:avLst/>
+          </a:prstGeom>
+          <a:noFill/>
+          <a:ln w="0">
+            <a:noFill/>
+            <a:prstDash val="solid"/>
+          </a:ln>
+        </p:spPr>
+        <p:txBody>
+          <a:bodyPr wrap="square" lIns="0" tIns="0" rIns="0" bIns="0" anchor="t">
+            <a:normAutofit/>
+          </a:bodyPr>
+          <a:lstStyle/>
+          <a:p>
+            <a:pPr algn="l">
+              <a:defRPr sz="1050" b="0">
+                <a:solidFill>
+                  <a:srgbClr val="8A8D91"/>
+                </a:solidFill>
+                <a:latin typeface="에스코어 드림 5 Medium"/>
+                <a:ea typeface="에스코어 드림 5 Medium"/>
+                <a:cs typeface="에스코어 드림 5 Medium"/>
+              </a:defRPr>
+            </a:pPr>
+            <a:r>
+              <a:rPr lang="ko-KR" altLang="en-US" sz="1050" b="0">
+                <a:solidFill>
+                  <a:srgbClr val="8A8D91"/>
+                </a:solidFill>
+                <a:latin typeface="에스코어 드림 5 Medium"/>
+                <a:ea typeface="에스코어 드림 5 Medium"/>
+                <a:cs typeface="에스코어 드림 5 Medium"/>
+              </a:rPr>
+              <a:t>팀 공유용 </a:t>
+            </a:r>
+            <a:r>
+              <a:rPr lang="en-US" altLang="ko-KR" sz="1050" b="0">
+                <a:solidFill>
+                  <a:srgbClr val="8A8D91"/>
+                </a:solidFill>
+                <a:latin typeface="에스코어 드림 5 Medium"/>
+                <a:ea typeface="에스코어 드림 5 Medium"/>
+                <a:cs typeface="에스코어 드림 5 Medium"/>
+              </a:rPr>
+              <a:t>· </a:t>
+            </a:r>
+            <a:r>
+              <a:rPr lang="ko-KR" altLang="en-US" sz="1050" b="0">
+                <a:solidFill>
+                  <a:srgbClr val="8A8D91"/>
+                </a:solidFill>
+                <a:latin typeface="에스코어 드림 5 Medium"/>
+                <a:ea typeface="에스코어 드림 5 Medium"/>
+                <a:cs typeface="에스코어 드림 5 Medium"/>
+              </a:rPr>
+              <a:t>내부 자료</a:t>
+            </a:r>
+          </a:p>
+        </p:txBody>
+      </p:sp>
+      <p:pic>
+        <p:nvPicPr>
+          <p:cNvPr id="16" name="Picture 15" descr="graph.png"/>
+          <p:cNvPicPr>
+            <a:picLocks noChangeAspect="1"/>
+          </p:cNvPicPr>
+          <p:nvPr/>
+        </p:nvPicPr>
+        <p:blipFill>
+          <a:blip r:embed="rId2"/>
+          <a:stretch>
+            <a:fillRect/>
+          </a:stretch>
+        </p:blipFill>
+        <p:spPr>
+          <a:xfrm>
+            <a:off x="2022514" y="1645920"/>
+            <a:ext cx="8146665" cy="4160520"/>
+          </a:xfrm>
+          <a:prstGeom prst="rect">
+            <a:avLst/>
+          </a:prstGeom>
+          <a:ln w="12700">
+            <a:solidFill>
+              <a:srgbClr val="D7DDE9"/>
+            </a:solidFill>
+          </a:ln>
+        </p:spPr>
+      </p:pic>
+      <p:sp>
+        <p:nvSpPr>
+          <p:cNvPr id="17" name="TextBox 16"/>
+          <p:cNvSpPr txBox="1"/>
+          <p:nvPr/>
+        </p:nvSpPr>
+        <p:spPr>
+          <a:xfrm>
+            <a:off x="1066647" y="5916168"/>
+            <a:ext cx="10058400" cy="457200"/>
+          </a:xfrm>
+          <a:prstGeom prst="rect">
+            <a:avLst/>
+          </a:prstGeom>
+          <a:noFill/>
+        </p:spPr>
+        <p:txBody>
+          <a:bodyPr wrap="square">
+            <a:spAutoFit/>
+          </a:bodyPr>
+          <a:lstStyle/>
+          <a:p>
+            <a:pPr algn="ctr"/>
+            <a:r>
+              <a:rPr sz="1300">
+                <a:solidFill>
+                  <a:srgbClr val="5F6880"/>
+                </a:solidFill>
+              </a:rPr>
+              <a:t>llm-wiki graph 출력(문서 24 · 링크 57)을 시각화 — 위키·related·마크다운 링크로 이어진 문서 지도</a:t>
+            </a:r>
+          </a:p>
+        </p:txBody>
+      </p:sp>
+    </p:spTree>
   </p:cSld>
   <p:clrMapOvr>
     <a:masterClrMapping/>

</xml_diff>